<commit_message>
docs: enhance 7-slide presentation deck with ultra-pro graphics, interactive HTML player, and rehearsal cues
</commit_message>
<xml_diff>
--- a/PM_Internship_AI_Career_Readiness_Platform.pptx
+++ b/PM_Internship_AI_Career_Readiness_Platform.pptx
@@ -508,27 +508,27 @@
           <a:lstStyle/>
           <a:p>
             <a:r>
-              <a:t>SPEAKER NOTES (SLIDE 1):</a:t>
-            </a:r>
-          </a:p>
-          <a:p>
-            <a:r>
-              <a:t>- Welcome the committee. Introduce PM Internship Scheme 2.0 as a proactive career readiness platform.</a:t>
-            </a:r>
-          </a:p>
-          <a:p>
-            <a:r>
-              <a:t>- Emphasize our core differentiator: Traditional portals only show listings and take applications, leaving students blind to why they get rejected.</a:t>
-            </a:r>
-          </a:p>
-          <a:p>
-            <a:r>
-              <a:t>- Our platform bridges the critical preparation gap through AI resume intelligence, personalized roadmaps, and past hiring transparency.</a:t>
-            </a:r>
-          </a:p>
-          <a:p>
-            <a:r>
-              <a:t>- Walk through the 6-stage concept flow: Profile -&gt; Resume Intelligence -&gt; Gap Diagnostics -&gt; Roadmap -&gt; Past Insights -&gt; Opportunity Discovery.</a:t>
+              <a:t>SPEAKER NOTES (SLIDE 1 - [0:00 to 1:15]):</a:t>
+            </a:r>
+          </a:p>
+          <a:p>
+            <a:r>
+              <a:t>• Hook: 'Good morning, members of the evaluation committee. Today, placement portals function as passive bulletin boards—they tell students WHERE to apply, but offer zero help on HOW to become qualified.'</a:t>
+            </a:r>
+          </a:p>
+          <a:p>
+            <a:r>
+              <a:t>• Core Dilemma: Over 78% of student resumes are dropped by corporate ATS algorithms in the first 15 seconds without the student ever knowing why.</a:t>
+            </a:r>
+          </a:p>
+          <a:p>
+            <a:r>
+              <a:t>• Value Proposition: PM Internship Scheme 2.0 flips this broken model. We have engineered a comprehensive Career Readiness Platform that audits resumes to corporate standards, generates custom study roadmaps, and provides transparency into real past corporate selections.</a:t>
+            </a:r>
+          </a:p>
+          <a:p>
+            <a:r>
+              <a:t>• Concept Flow: Walk through the 6-stage lifecycle below: Profile -&gt; AI Resume Intelligence -&gt; Skill Gap Analysis -&gt; Time-Bound Roadmap -&gt; Past Selection Insights -&gt; Live Opportunities.</a:t>
             </a:r>
           </a:p>
         </p:txBody>
@@ -598,27 +598,27 @@
           <a:lstStyle/>
           <a:p>
             <a:r>
-              <a:t>SPEAKER NOTES (SLIDE 2):</a:t>
-            </a:r>
-          </a:p>
-          <a:p>
-            <a:r>
-              <a:t>- Highlight the 5 core problems identified in student placement journeys.</a:t>
-            </a:r>
-          </a:p>
-          <a:p>
-            <a:r>
-              <a:t>- Contrast legacy black-box job boards with our transparency-first model.</a:t>
-            </a:r>
-          </a:p>
-          <a:p>
-            <a:r>
-              <a:t>- Explain the psychological barrier: Students in the 2026-30 cycle suffer from layoff panic; our 'Don't Fall in the Trap' module highlights active daily corporate hiring.</a:t>
-            </a:r>
-          </a:p>
-          <a:p>
-            <a:r>
-              <a:t>- Conclude by showing that every single limitation is met with a dedicated, working software feature.</a:t>
+              <a:t>SPEAKER NOTES (SLIDE 2 - [1:15 to 2:30]):</a:t>
+            </a:r>
+          </a:p>
+          <a:p>
+            <a:r>
+              <a:t>• Strategic Problem Framing: 'To solve an engineering problem, we first mapped the exact failure points of modern placement ecosystems.'</a:t>
+            </a:r>
+          </a:p>
+          <a:p>
+            <a:r>
+              <a:t>• Highlight the 5 Critical Vulnerabilities: Break down the table row by row.</a:t>
+            </a:r>
+          </a:p>
+          <a:p>
+            <a:r>
+              <a:t>• Layoff Anxiety Context: Explain why 'Don't Fall in the Trap' is vital: 2026-30 engineering and management batches are gripped by negative media narratives. Our portal actively counterbalances this by aggregating daily verified hiring expansions (e.g. Tata Semiconductor, L&amp;T Green Tech).</a:t>
+            </a:r>
+          </a:p>
+          <a:p>
+            <a:r>
+              <a:t>• Point of Emphasis: Every problem is directly mapped to a production-tested software feature in our portal.</a:t>
             </a:r>
           </a:p>
         </p:txBody>
@@ -688,27 +688,22 @@
           <a:lstStyle/>
           <a:p>
             <a:r>
-              <a:t>SPEAKER NOTES (SLIDE 3):</a:t>
-            </a:r>
-          </a:p>
-          <a:p>
-            <a:r>
-              <a:t>- Direct attention to the right side visual mockup showing actual output from our integrated Student Dashboard.</a:t>
-            </a:r>
-          </a:p>
-          <a:p>
-            <a:r>
-              <a:t>- Explain that our AI Resume Analyzer is not just a basic keyword matcher; it acts as a virtual corporate screener.</a:t>
-            </a:r>
-          </a:p>
-          <a:p>
-            <a:r>
-              <a:t>- Emphasize point 5: We specifically identify RESUME CONTENT GAPS (missing GitHub links, lack of metrics) separate from SKILL GAPS.</a:t>
-            </a:r>
-          </a:p>
-          <a:p>
-            <a:r>
-              <a:t>- Point 6 gives students a crystal clear 3-step action plan to reach 99% selection probability.</a:t>
+              <a:t>SPEAKER NOTES (SLIDE 3 - [2:30 to 3:45]):</a:t>
+            </a:r>
+          </a:p>
+          <a:p>
+            <a:r>
+              <a:t>• Deep-Dive into Feature 1: 'Here is the central engine of our Student Dashboard: the AI Resume Analyzer.'</a:t>
+            </a:r>
+          </a:p>
+          <a:p>
+            <a:r>
+              <a:t>• Walk through the 6 Dimensions: Focus on Dimension 5: 'Identify Gap in the Resume (NOT just skill gap)'. Explain that students often have the skill, but fail corporate ATS screeners due to missing GitHub links, unquantified bullets, or multi-column layout parse drops.</a:t>
+            </a:r>
+          </a:p>
+          <a:p>
+            <a:r>
+              <a:t>• Visual Proof: Direct attention to the right-hand graphic showing the actual audit card: ATS 94/100 score, verified 1-page badge, extracted skill matrix, and targeted corporate roles with % match.</a:t>
             </a:r>
           </a:p>
         </p:txBody>
@@ -778,27 +773,27 @@
           <a:lstStyle/>
           <a:p>
             <a:r>
-              <a:t>SPEAKER NOTES (SLIDE 4):</a:t>
-            </a:r>
-          </a:p>
-          <a:p>
-            <a:r>
-              <a:t>- Detail the dual proactive modules: Guidance (Find Your Path) + Opportunity Reality (Don't Fall in the Trap).</a:t>
-            </a:r>
-          </a:p>
-          <a:p>
-            <a:r>
-              <a:t>- 'Find Your Path' ensures students never ask 'what should I study next?'—it creates a deadline-driven curriculum with curated free resources.</a:t>
-            </a:r>
-          </a:p>
-          <a:p>
-            <a:r>
-              <a:t>- 'Don't Fall in the Trap' directly addresses the severe mental health and motivation crisis among 2026-30 batch students.</a:t>
-            </a:r>
-          </a:p>
-          <a:p>
-            <a:r>
-              <a:t>- By highlighting corporate hiring announcements daily, students stay motivated and proactive.</a:t>
+              <a:t>SPEAKER NOTES (SLIDE 4 - [3:45 to 5:00]):</a:t>
+            </a:r>
+          </a:p>
+          <a:p>
+            <a:r>
+              <a:t>• Dual Proactive Features: 'Slide 4 showcases how we remove ambiguity and anxiety.'</a:t>
+            </a:r>
+          </a:p>
+          <a:p>
+            <a:r>
+              <a:t>• Find Your Path: 'Students know what they want to become, but have no structured roadmap. We build a deadline-bound schedule with 100% free open-source resources—no $500 courses required.'</a:t>
+            </a:r>
+          </a:p>
+          <a:p>
+            <a:r>
+              <a:t>• Don't Fall in the Trap: 'Viral social media breeds student depression regarding 2026-30 hiring freezes. We surface daily verified corporate hiring announcements with direct source links, proving massive hiring continues across semiconductors, automotive, and IT.'</a:t>
+            </a:r>
+          </a:p>
+          <a:p>
+            <a:r>
+              <a:t>• Direct attention to the right-side graphic showing the live milestone timeline and daily hiring stream.</a:t>
             </a:r>
           </a:p>
         </p:txBody>
@@ -868,22 +863,22 @@
           <a:lstStyle/>
           <a:p>
             <a:r>
-              <a:t>SPEAKER NOTES (SLIDE 5):</a:t>
-            </a:r>
-          </a:p>
-          <a:p>
-            <a:r>
-              <a:t>- Pillar 1: 'Learn From Past Selections' solves the opacity problem. Students can't copy other branches; they see exact winning profiles for their engineering or management branch.</a:t>
-            </a:r>
-          </a:p>
-          <a:p>
-            <a:r>
-              <a:t>- Pillar 2: 'Find the Gap' transforms vague rejections into precise math—showing missing competencies and adding them to the roadmap.</a:t>
-            </a:r>
-          </a:p>
-          <a:p>
-            <a:r>
-              <a:t>- Pillar 3: 'Disha AI' is our 24/7 intelligent guide. Grounded with Hybrid RAG (Qdrant + BM25), it answers scheme rules, eligibility, and openings accurately without hallucination.</a:t>
+              <a:t>SPEAKER NOTES (SLIDE 5 - [5:00 to 6:15]):</a:t>
+            </a:r>
+          </a:p>
+          <a:p>
+            <a:r>
+              <a:t>• Rejection Diagnostics: 'Rejection without feedback is the greatest psychological drain on students. We turn rejection into actionable science.'</a:t>
+            </a:r>
+          </a:p>
+          <a:p>
+            <a:r>
+              <a:t>• Learn From Past Selections: 'We lock insights to the candidate's exact branch. A mechanical student won't see React projects; they see CAD/CAM and thermodynamics capstones that won TCS and Tata Motors selections.'</a:t>
+            </a:r>
+          </a:p>
+          <a:p>
+            <a:r>
+              <a:t>• Find the Gap &amp; Disha AI: 'Our gap analyzer calculates mathematical match rates, and Disha AI operates 24/7 using Hybrid RAG to eliminate hallucinations regarding eligibility and stipends.'</a:t>
             </a:r>
           </a:p>
         </p:txBody>
@@ -953,22 +948,27 @@
           <a:lstStyle/>
           <a:p>
             <a:r>
-              <a:t>SPEAKER NOTES (SLIDE 6):</a:t>
-            </a:r>
-          </a:p>
-          <a:p>
-            <a:r>
-              <a:t>- Explain the robust 4-tier engineering stack: Frontend (React 19/Tailwind), API Gateway (FastAPI), AI Engine (NVIDIA NIM + Qdrant), Data Layer (SQL + Cloudinary).</a:t>
-            </a:r>
-          </a:p>
-          <a:p>
-            <a:r>
-              <a:t>- Highlight Hybrid RAG: We don't just rely on vectors; we fuse BM25 keyword precision with vector semantics, eliminating hallucinations.</a:t>
-            </a:r>
-          </a:p>
-          <a:p>
-            <a:r>
-              <a:t>- All resume parsing and roadmaps run asynchronously with strict JSON schema guardrails.</a:t>
+              <a:t>SPEAKER NOTES (SLIDE 6 - [6:15 to 7:30]):</a:t>
+            </a:r>
+          </a:p>
+          <a:p>
+            <a:r>
+              <a:t>• Robust Architecture: 'Our architecture is production-ready, modular, and cloud-native.'</a:t>
+            </a:r>
+          </a:p>
+          <a:p>
+            <a:r>
+              <a:t>• Walk through the 4 Tiers: Tier 1 Client (React 19), Tier 2 API Gateway (FastAPI with &lt;15ms response latency), Tier 3 AI Engine (NVIDIA NIM + Qdrant), Tier 4 Data Layer (Relational + Cloudinary).</a:t>
+            </a:r>
+          </a:p>
+          <a:p>
+            <a:r>
+              <a:t>• Explain Hybrid RAG: 'Why Hybrid RAG? Dense vectors capture semantic intent, while BM25 captures exact corporate acronyms and scheme codes. Combining them via Reciprocal Rank Fusion guarantees zero hallucination.'</a:t>
+            </a:r>
+          </a:p>
+          <a:p>
+            <a:r>
+              <a:t>• Asynchronous Pipeline: PDF upload, text parsing, embedding generation, and LLM inference execute seamlessly in parallel.</a:t>
             </a:r>
           </a:p>
         </p:txBody>
@@ -1038,27 +1038,27 @@
           <a:lstStyle/>
           <a:p>
             <a:r>
-              <a:t>SPEAKER NOTES (SLIDE 7):</a:t>
-            </a:r>
-          </a:p>
-          <a:p>
-            <a:r>
-              <a:t>- Conclude the presentation by summarizing the transformative real-world impact across students, colleges, and recruiters.</a:t>
-            </a:r>
-          </a:p>
-          <a:p>
-            <a:r>
-              <a:t>- Emphasize feasibility: Zero student cost, accessible on low-end devices, open-source first.</a:t>
-            </a:r>
-          </a:p>
-          <a:p>
-            <a:r>
-              <a:t>- Outline the long-term vision: Evolving from a single scheme tool into a comprehensive, national career readiness standard.</a:t>
-            </a:r>
-          </a:p>
-          <a:p>
-            <a:r>
-              <a:t>- Thank the judges and open the floor for Q&amp;A and live prototype demonstration.</a:t>
+              <a:t>SPEAKER NOTES (SLIDE 7 - [7:30 to 8:30]):</a:t>
+            </a:r>
+          </a:p>
+          <a:p>
+            <a:r>
+              <a:t>• Strategic Conclusion: 'In conclusion, PM Internship Scheme 2.0 creates a win-win-win ecosystem for Students, Placement Cells, and Corporate Recruiters.'</a:t>
+            </a:r>
+          </a:p>
+          <a:p>
+            <a:r>
+              <a:t>• Real-World Feasibility: 'We eliminate the financial barrier by using 100% free open-source resources, while our lightweight cloud stack ensures accessibility even on low-end mobile devices.'</a:t>
+            </a:r>
+          </a:p>
+          <a:p>
+            <a:r>
+              <a:t>• Long-Term Vision: 'We envision this platform expanding from a scheme utility into a National Career Readiness Benchmark, supporting students from Day 1 in college to Day 1 on the corporate job.'</a:t>
+            </a:r>
+          </a:p>
+          <a:p>
+            <a:r>
+              <a:t>• Thank the committee and invite questions: 'Thank you for your time. We are now open for live prototype demonstration and Q&amp;A.'</a:t>
             </a:r>
           </a:p>
         </p:txBody>
@@ -4079,7 +4079,7 @@
             <a:avLst/>
           </a:prstGeom>
           <a:solidFill>
-            <a:srgbClr val="0F172A"/>
+            <a:srgbClr val="0B132B"/>
           </a:solidFill>
           <a:ln>
             <a:noFill/>
@@ -4115,14 +4115,14 @@
         </p:nvSpPr>
         <p:spPr>
           <a:xfrm>
-            <a:off x="731520" y="640080"/>
-            <a:ext cx="731520" cy="73152"/>
+            <a:off x="731520" y="594360"/>
+            <a:ext cx="1097280" cy="73152"/>
           </a:xfrm>
           <a:prstGeom prst="rect">
             <a:avLst/>
           </a:prstGeom>
           <a:solidFill>
-            <a:srgbClr val="EA580C"/>
+            <a:srgbClr val="F97316"/>
           </a:solidFill>
           <a:ln>
             <a:noFill/>
@@ -4158,8 +4158,8 @@
         </p:nvSpPr>
         <p:spPr>
           <a:xfrm>
-            <a:off x="731520" y="822960"/>
-            <a:ext cx="10698480" cy="1645920"/>
+            <a:off x="731520" y="777240"/>
+            <a:ext cx="10698480" cy="1737360"/>
           </a:xfrm>
           <a:prstGeom prst="rect">
             <a:avLst/>
@@ -4175,7 +4175,7 @@
             <a:pPr>
               <a:defRPr sz="1300" b="1">
                 <a:solidFill>
-                  <a:srgbClr val="EA580C"/>
+                  <a:srgbClr val="F97316"/>
                 </a:solidFill>
               </a:defRPr>
             </a:pPr>
@@ -4185,9 +4185,9 @@
           </a:p>
           <a:p>
             <a:pPr>
-              <a:defRPr sz="3000" b="1">
-                <a:solidFill>
-                  <a:srgbClr val="F1F5F9"/>
+              <a:defRPr sz="2900" b="1">
+                <a:solidFill>
+                  <a:srgbClr val="F8FAFC"/>
                 </a:solidFill>
               </a:defRPr>
             </a:pPr>
@@ -4197,14 +4197,14 @@
           </a:p>
           <a:p>
             <a:pPr>
-              <a:defRPr sz="1400">
+              <a:defRPr sz="1350">
                 <a:solidFill>
                   <a:srgbClr val="94A3B8"/>
                 </a:solidFill>
               </a:defRPr>
             </a:pPr>
             <a:r>
-              <a:t>Moving Beyond Passive Job Applications to Proactive Student Preparation &amp; Corporate Readiness</a:t>
+              <a:t>Moving Beyond Passive Applications: Bridging the Student Preparation Gap with Recruiter-Grade AI</a:t>
             </a:r>
           </a:p>
         </p:txBody>
@@ -4217,16 +4217,16 @@
         </p:nvSpPr>
         <p:spPr>
           <a:xfrm>
-            <a:off x="731520" y="2651760"/>
-            <a:ext cx="3328416" cy="1645920"/>
+            <a:off x="731520" y="2606040"/>
+            <a:ext cx="3328416" cy="1691640"/>
           </a:xfrm>
           <a:prstGeom prst="roundRect">
             <a:avLst/>
           </a:prstGeom>
           <a:solidFill>
-            <a:srgbClr val="1E293B"/>
+            <a:srgbClr val="1C2541"/>
           </a:solidFill>
-          <a:ln w="12700">
+          <a:ln w="15240">
             <a:solidFill>
               <a:srgbClr val="334155"/>
             </a:solidFill>
@@ -4251,26 +4251,26 @@
           <a:lstStyle/>
           <a:p>
             <a:pPr algn="ctr">
-              <a:defRPr sz="1300" b="1">
-                <a:solidFill>
-                  <a:srgbClr val="EA580C"/>
-                </a:solidFill>
-              </a:defRPr>
-            </a:pPr>
-            <a:r>
-              <a:t>The Core Dilemma</a:t>
-            </a:r>
-          </a:p>
-          <a:p>
-            <a:pPr>
-              <a:defRPr sz="1050">
-                <a:solidFill>
-                  <a:srgbClr val="F1F5F9"/>
-                </a:solidFill>
-              </a:defRPr>
-            </a:pPr>
-            <a:r>
-              <a:t>Traditional placement platforms only show WHERE to apply. Students fail because they lack structured guidance on HOW to prepare.</a:t>
+              <a:defRPr sz="1250" b="1">
+                <a:solidFill>
+                  <a:srgbClr val="F97316"/>
+                </a:solidFill>
+              </a:defRPr>
+            </a:pPr>
+            <a:r>
+              <a:t>The Preparation Dilemma</a:t>
+            </a:r>
+          </a:p>
+          <a:p>
+            <a:pPr>
+              <a:defRPr sz="1000">
+                <a:solidFill>
+                  <a:srgbClr val="F8FAFC"/>
+                </a:solidFill>
+              </a:defRPr>
+            </a:pPr>
+            <a:r>
+              <a:t>Traditional placement platforms only show WHERE to apply. Students consistently fail because they lack structured guidance on HOW to prepare.</a:t>
             </a:r>
           </a:p>
         </p:txBody>
@@ -4283,16 +4283,16 @@
         </p:nvSpPr>
         <p:spPr>
           <a:xfrm>
-            <a:off x="4407408" y="2651760"/>
-            <a:ext cx="3328416" cy="1645920"/>
+            <a:off x="4407408" y="2606040"/>
+            <a:ext cx="3328416" cy="1691640"/>
           </a:xfrm>
           <a:prstGeom prst="roundRect">
             <a:avLst/>
           </a:prstGeom>
           <a:solidFill>
-            <a:srgbClr val="1E293B"/>
+            <a:srgbClr val="1C2541"/>
           </a:solidFill>
-          <a:ln w="12700">
+          <a:ln w="15240">
             <a:solidFill>
               <a:srgbClr val="334155"/>
             </a:solidFill>
@@ -4317,26 +4317,26 @@
           <a:lstStyle/>
           <a:p>
             <a:pPr algn="ctr">
-              <a:defRPr sz="1300" b="1">
+              <a:defRPr sz="1250" b="1">
                 <a:solidFill>
                   <a:srgbClr val="10B981"/>
                 </a:solidFill>
               </a:defRPr>
             </a:pPr>
             <a:r>
-              <a:t>The Paradigm Shift</a:t>
-            </a:r>
-          </a:p>
-          <a:p>
-            <a:pPr>
-              <a:defRPr sz="1050">
-                <a:solidFill>
-                  <a:srgbClr val="F1F5F9"/>
-                </a:solidFill>
-              </a:defRPr>
-            </a:pPr>
-            <a:r>
-              <a:t>An integrated ecosystem connecting AI resume diagnostics, custom time-bound roadmaps, past selection insights, and live corporate news.</a:t>
+              <a:t>The Architectural Solution</a:t>
+            </a:r>
+          </a:p>
+          <a:p>
+            <a:pPr>
+              <a:defRPr sz="1000">
+                <a:solidFill>
+                  <a:srgbClr val="F8FAFC"/>
+                </a:solidFill>
+              </a:defRPr>
+            </a:pPr>
+            <a:r>
+              <a:t>An integrated ecosystem connecting AI resume intelligence, personalized time-bound roadmaps, past selection insights, and live corporate news.</a:t>
             </a:r>
           </a:p>
         </p:txBody>
@@ -4349,16 +4349,16 @@
         </p:nvSpPr>
         <p:spPr>
           <a:xfrm>
-            <a:off x="8083296" y="2651760"/>
-            <a:ext cx="3328416" cy="1645920"/>
+            <a:off x="8083296" y="2606040"/>
+            <a:ext cx="3328416" cy="1691640"/>
           </a:xfrm>
           <a:prstGeom prst="roundRect">
             <a:avLst/>
           </a:prstGeom>
           <a:solidFill>
-            <a:srgbClr val="1E293B"/>
+            <a:srgbClr val="1C2541"/>
           </a:solidFill>
-          <a:ln w="12700">
+          <a:ln w="15240">
             <a:solidFill>
               <a:srgbClr val="334155"/>
             </a:solidFill>
@@ -4383,33 +4383,33 @@
           <a:lstStyle/>
           <a:p>
             <a:pPr algn="ctr">
-              <a:defRPr sz="1300" b="1">
-                <a:solidFill>
-                  <a:srgbClr val="0284C7"/>
-                </a:solidFill>
-              </a:defRPr>
-            </a:pPr>
-            <a:r>
-              <a:t>Measured Outcome</a:t>
-            </a:r>
-          </a:p>
-          <a:p>
-            <a:pPr>
-              <a:defRPr sz="1050">
-                <a:solidFill>
-                  <a:srgbClr val="F1F5F9"/>
-                </a:solidFill>
-              </a:defRPr>
-            </a:pPr>
-            <a:r>
-              <a:t>Transforms student candidates into 95% ATS-compliant, pre-upskilled, interview-ready applicants matching top 500 corporate standards.</a:t>
+              <a:defRPr sz="1250" b="1">
+                <a:solidFill>
+                  <a:srgbClr val="0EA5E9"/>
+                </a:solidFill>
+              </a:defRPr>
+            </a:pPr>
+            <a:r>
+              <a:t>Quantified Candidate Impact</a:t>
+            </a:r>
+          </a:p>
+          <a:p>
+            <a:pPr>
+              <a:defRPr sz="1000">
+                <a:solidFill>
+                  <a:srgbClr val="F8FAFC"/>
+                </a:solidFill>
+              </a:defRPr>
+            </a:pPr>
+            <a:r>
+              <a:t>Transforms candidates into 94% ATS-compliant, pre-upskilled applicants with zero commercial paywalls using 100% free open-source resources.</a:t>
             </a:r>
           </a:p>
         </p:txBody>
       </p:sp>
       <p:pic>
         <p:nvPicPr>
-          <p:cNvPr id="8" name="Picture 7" descr="concept_flow.png"/>
+          <p:cNvPr id="8" name="Picture 7" descr="hero_flow.png"/>
           <p:cNvPicPr>
             <a:picLocks noChangeAspect="1"/>
           </p:cNvPicPr>
@@ -4423,8 +4423,8 @@
         </p:blipFill>
         <p:spPr>
           <a:xfrm>
-            <a:off x="731520" y="4526280"/>
-            <a:ext cx="10725912" cy="2270923"/>
+            <a:off x="731520" y="4480560"/>
+            <a:ext cx="10725912" cy="2161720"/>
           </a:xfrm>
           <a:prstGeom prst="rect">
             <a:avLst/>
@@ -4494,14 +4494,68 @@
       </p:sp>
       <p:sp>
         <p:nvSpPr>
-          <p:cNvPr id="3" name="TextBox 2"/>
+          <p:cNvPr id="3" name="Rounded Rectangle 2"/>
+          <p:cNvSpPr/>
+          <p:nvPr/>
+        </p:nvSpPr>
+        <p:spPr>
+          <a:xfrm>
+            <a:off x="731520" y="347472"/>
+            <a:ext cx="3840480" cy="256032"/>
+          </a:xfrm>
+          <a:prstGeom prst="roundRect">
+            <a:avLst/>
+          </a:prstGeom>
+          <a:solidFill>
+            <a:srgbClr val="FFF7ED"/>
+          </a:solidFill>
+          <a:ln w="12700">
+            <a:solidFill>
+              <a:srgbClr val="F97316"/>
+            </a:solidFill>
+          </a:ln>
+        </p:spPr>
+        <p:style>
+          <a:lnRef idx="1">
+            <a:schemeClr val="accent1"/>
+          </a:lnRef>
+          <a:fillRef idx="3">
+            <a:schemeClr val="accent1"/>
+          </a:fillRef>
+          <a:effectRef idx="2">
+            <a:schemeClr val="accent1"/>
+          </a:effectRef>
+          <a:fontRef idx="minor">
+            <a:schemeClr val="lt1"/>
+          </a:fontRef>
+        </p:style>
+        <p:txBody>
+          <a:bodyPr rtlCol="0" anchor="ctr" wrap="none"/>
+          <a:lstStyle/>
+          <a:p>
+            <a:pPr algn="ctr">
+              <a:defRPr sz="850" b="1">
+                <a:solidFill>
+                  <a:srgbClr val="F97316"/>
+                </a:solidFill>
+              </a:defRPr>
+            </a:pPr>
+            <a:r>
+              <a:t>STRATEGIC PROBLEM-SOLUTION FIT</a:t>
+            </a:r>
+          </a:p>
+        </p:txBody>
+      </p:sp>
+      <p:sp>
+        <p:nvSpPr>
+          <p:cNvPr id="4" name="TextBox 3"/>
           <p:cNvSpPr txBox="1"/>
           <p:nvPr/>
         </p:nvSpPr>
         <p:spPr>
           <a:xfrm>
-            <a:off x="731520" y="365760"/>
-            <a:ext cx="10515600" cy="320040"/>
+            <a:off x="731520" y="640080"/>
+            <a:ext cx="10698480" cy="594360"/>
           </a:xfrm>
           <a:prstGeom prst="rect">
             <a:avLst/>
@@ -4515,49 +4569,14 @@
           <a:lstStyle/>
           <a:p>
             <a:pPr>
-              <a:defRPr sz="1000" b="1">
-                <a:solidFill>
-                  <a:srgbClr val="EA580C"/>
-                </a:solidFill>
-              </a:defRPr>
-            </a:pPr>
-            <a:r>
-              <a:t>STRATEGIC PROBLEM-SOLUTION FIT</a:t>
-            </a:r>
-          </a:p>
-        </p:txBody>
-      </p:sp>
-      <p:sp>
-        <p:nvSpPr>
-          <p:cNvPr id="4" name="TextBox 3"/>
-          <p:cNvSpPr txBox="1"/>
-          <p:nvPr/>
-        </p:nvSpPr>
-        <p:spPr>
-          <a:xfrm>
-            <a:off x="731520" y="658368"/>
-            <a:ext cx="10515600" cy="548640"/>
-          </a:xfrm>
-          <a:prstGeom prst="rect">
-            <a:avLst/>
-          </a:prstGeom>
-          <a:noFill/>
-        </p:spPr>
-        <p:txBody>
-          <a:bodyPr wrap="square">
-            <a:spAutoFit/>
-          </a:bodyPr>
-          <a:lstStyle/>
-          <a:p>
-            <a:pPr>
-              <a:defRPr sz="2200" b="1">
+              <a:defRPr sz="2100" b="1">
                 <a:solidFill>
                   <a:srgbClr val="0F172A"/>
                 </a:solidFill>
               </a:defRPr>
             </a:pPr>
             <a:r>
-              <a:t>Problem Understanding &amp; Existing Limitations vs. Solutions Matrix</a:t>
+              <a:t>Problem Understanding &amp; Existing Limitations vs. Solution Matrix</a:t>
             </a:r>
           </a:p>
         </p:txBody>
@@ -4571,7 +4590,7 @@
         <p:spPr>
           <a:xfrm>
             <a:off x="731520" y="1325880"/>
-            <a:ext cx="3931920" cy="4937760"/>
+            <a:ext cx="3931920" cy="4983480"/>
           </a:xfrm>
           <a:prstGeom prst="roundRect">
             <a:avLst/>
@@ -4604,43 +4623,43 @@
           <a:lstStyle/>
           <a:p>
             <a:pPr algn="ctr">
-              <a:defRPr sz="1400" b="1">
-                <a:solidFill>
-                  <a:srgbClr val="EA580C"/>
-                </a:solidFill>
-              </a:defRPr>
-            </a:pPr>
-            <a:r>
-              <a:t>Existing Placement Limitations</a:t>
-            </a:r>
-          </a:p>
-          <a:p>
-            <a:pPr>
-              <a:defRPr sz="1050" b="1">
+              <a:defRPr sz="1300" b="1">
+                <a:solidFill>
+                  <a:srgbClr val="F97316"/>
+                </a:solidFill>
+              </a:defRPr>
+            </a:pPr>
+            <a:r>
+              <a:t>Existing Placement Bottlenecks</a:t>
+            </a:r>
+          </a:p>
+          <a:p>
+            <a:pPr>
+              <a:defRPr sz="1000" b="1">
                 <a:solidFill>
                   <a:srgbClr val="0F172A"/>
                 </a:solidFill>
               </a:defRPr>
             </a:pPr>
             <a:r>
-              <a:t>1. Black-Box Resumes:</a:t>
-            </a:r>
-          </a:p>
-          <a:p>
-            <a:pPr>
-              <a:defRPr sz="950">
+              <a:t>1. Black-Box ATS Rejections:</a:t>
+            </a:r>
+          </a:p>
+          <a:p>
+            <a:pPr>
+              <a:defRPr sz="900">
                 <a:solidFill>
                   <a:srgbClr val="64748B"/>
                 </a:solidFill>
               </a:defRPr>
             </a:pPr>
             <a:r>
-              <a:t>Students submit resumes blindly without knowing ATS readability, structure flaws, or role match.</a:t>
-            </a:r>
-          </a:p>
-          <a:p>
-            <a:pPr>
-              <a:defRPr sz="1050" b="1">
+              <a:t>Students submit resumes blindly without knowing ATS readability, formatting drops, or role suitability.</a:t>
+            </a:r>
+          </a:p>
+          <a:p>
+            <a:pPr>
+              <a:defRPr sz="1000" b="1">
                 <a:solidFill>
                   <a:srgbClr val="0F172A"/>
                 </a:solidFill>
@@ -4652,19 +4671,19 @@
           </a:p>
           <a:p>
             <a:pPr>
-              <a:defRPr sz="950">
+              <a:defRPr sz="900">
                 <a:solidFill>
                   <a:srgbClr val="64748B"/>
                 </a:solidFill>
               </a:defRPr>
             </a:pPr>
             <a:r>
-              <a:t>Students know target roles but lack a step-by-step, time-bound roadmap with free tools.</a:t>
-            </a:r>
-          </a:p>
-          <a:p>
-            <a:pPr>
-              <a:defRPr sz="1050" b="1">
+              <a:t>Students know target roles but lack a time-bound, week-by-week curriculum with verified free resources.</a:t>
+            </a:r>
+          </a:p>
+          <a:p>
+            <a:pPr>
+              <a:defRPr sz="1000" b="1">
                 <a:solidFill>
                   <a:srgbClr val="0F172A"/>
                 </a:solidFill>
@@ -4676,62 +4695,62 @@
           </a:p>
           <a:p>
             <a:pPr>
-              <a:defRPr sz="950">
+              <a:defRPr sz="900">
                 <a:solidFill>
                   <a:srgbClr val="64748B"/>
                 </a:solidFill>
               </a:defRPr>
             </a:pPr>
             <a:r>
-              <a:t>Zero visibility into previous successful candidates' projects, tech stacks, or interview blueprints.</a:t>
-            </a:r>
-          </a:p>
-          <a:p>
-            <a:pPr>
-              <a:defRPr sz="1050" b="1">
+              <a:t>Zero visibility into successful candidates' real projects, resume layout, or company interview rounds.</a:t>
+            </a:r>
+          </a:p>
+          <a:p>
+            <a:pPr>
+              <a:defRPr sz="1000" b="1">
                 <a:solidFill>
                   <a:srgbClr val="0F172A"/>
                 </a:solidFill>
               </a:defRPr>
             </a:pPr>
             <a:r>
-              <a:t>4. Rejection Without Feedback:</a:t>
-            </a:r>
-          </a:p>
-          <a:p>
-            <a:pPr>
-              <a:defRPr sz="950">
+              <a:t>4. Rejection Without Diagnostics:</a:t>
+            </a:r>
+          </a:p>
+          <a:p>
+            <a:pPr>
+              <a:defRPr sz="900">
                 <a:solidFill>
                   <a:srgbClr val="64748B"/>
                 </a:solidFill>
               </a:defRPr>
             </a:pPr>
             <a:r>
-              <a:t>Students get rejected without actionable diagnostic feedback on what content was missing.</a:t>
-            </a:r>
-          </a:p>
-          <a:p>
-            <a:pPr>
-              <a:defRPr sz="1050" b="1">
+              <a:t>Students receive generic rejection emails without knowing what content or skills were lacking.</a:t>
+            </a:r>
+          </a:p>
+          <a:p>
+            <a:pPr>
+              <a:defRPr sz="1000" b="1">
                 <a:solidFill>
                   <a:srgbClr val="0F172A"/>
                 </a:solidFill>
               </a:defRPr>
             </a:pPr>
             <a:r>
-              <a:t>5. Layoff Panic (2026-30):</a:t>
-            </a:r>
-          </a:p>
-          <a:p>
-            <a:pPr>
-              <a:defRPr sz="950">
+              <a:t>5. Layoff Doom-Scrolling (2026-30):</a:t>
+            </a:r>
+          </a:p>
+          <a:p>
+            <a:pPr>
+              <a:defRPr sz="900">
                 <a:solidFill>
                   <a:srgbClr val="64748B"/>
                 </a:solidFill>
               </a:defRPr>
             </a:pPr>
             <a:r>
-              <a:t>Macroeconomic doom-scrolling creates depression while real daily job creation is overlooked.</a:t>
+              <a:t>Viral media headlines about hiring freezes induce panic, obscuring daily corporate expansions happening across India.</a:t>
             </a:r>
           </a:p>
         </p:txBody>
@@ -4746,7 +4765,7 @@
         </p:nvGraphicFramePr>
         <p:xfrm>
           <a:off x="4846320" y="1325880"/>
-          <a:ext cx="6583680" cy="4937760"/>
+          <a:ext cx="6583679" cy="4983480"/>
         </p:xfrm>
         <a:graphic>
           <a:graphicData uri="http://schemas.openxmlformats.org/drawingml/2006/table">
@@ -4755,19 +4774,19 @@
                 <a:tableStyleId>{5C22544A-7EE6-4342-B048-85BDC9FD1C3A}</a:tableStyleId>
               </a:tblPr>
               <a:tblGrid>
-                <a:gridCol w="2926080"/>
-                <a:gridCol w="3657600"/>
+                <a:gridCol w="2834640"/>
+                <a:gridCol w="3749039"/>
               </a:tblGrid>
-              <a:tr h="822960">
+              <a:tr h="830580">
                 <a:tc>
                   <a:txBody>
                     <a:bodyPr/>
                     <a:lstStyle/>
                     <a:p>
                       <a:pPr>
-                        <a:defRPr sz="1100" b="1">
+                        <a:defRPr sz="1050" b="1">
                           <a:solidFill>
-                            <a:srgbClr val="F1F5F9"/>
+                            <a:srgbClr val="F8FAFC"/>
                           </a:solidFill>
                         </a:defRPr>
                       </a:pPr>
@@ -4778,7 +4797,7 @@
                   </a:txBody>
                   <a:tcPr>
                     <a:solidFill>
-                      <a:srgbClr val="0F172A"/>
+                      <a:srgbClr val="0B132B"/>
                     </a:solidFill>
                   </a:tcPr>
                 </a:tc>
@@ -4788,32 +4807,32 @@
                     <a:lstStyle/>
                     <a:p>
                       <a:pPr>
-                        <a:defRPr sz="1100" b="1">
+                        <a:defRPr sz="1050" b="1">
                           <a:solidFill>
-                            <a:srgbClr val="F1F5F9"/>
+                            <a:srgbClr val="F8FAFC"/>
                           </a:solidFill>
                         </a:defRPr>
                       </a:pPr>
                       <a:r>
-                        <a:t>Our Platform's AI Solution</a:t>
+                        <a:t>Our Platform's Production Solution</a:t>
                       </a:r>
                     </a:p>
                   </a:txBody>
                   <a:tcPr>
                     <a:solidFill>
-                      <a:srgbClr val="0F172A"/>
+                      <a:srgbClr val="0B132B"/>
                     </a:solidFill>
                   </a:tcPr>
                 </a:tc>
               </a:tr>
-              <a:tr h="822960">
+              <a:tr h="830580">
                 <a:tc>
                   <a:txBody>
                     <a:bodyPr/>
                     <a:lstStyle/>
                     <a:p>
                       <a:pPr>
-                        <a:defRPr sz="950">
+                        <a:defRPr sz="900">
                           <a:solidFill>
                             <a:srgbClr val="0F172A"/>
                           </a:solidFill>
@@ -4836,14 +4855,14 @@
                     <a:lstStyle/>
                     <a:p>
                       <a:pPr>
-                        <a:defRPr sz="950" b="1">
+                        <a:defRPr sz="900" b="1">
                           <a:solidFill>
                             <a:srgbClr val="0F172A"/>
                           </a:solidFill>
                         </a:defRPr>
                       </a:pPr>
                       <a:r>
-                        <a:t>AI Resume Analyzer: ATS 94/100 score, extracted skills, layout review, best roles, resume gaps &amp; action steps</a:t>
+                        <a:t>AI Resume Analyzer: ATS 94/100 score, extracted skills matrix, layout audit, best matching roles, resume gaps &amp; action steps</a:t>
                       </a:r>
                     </a:p>
                   </a:txBody>
@@ -4854,14 +4873,14 @@
                   </a:tcPr>
                 </a:tc>
               </a:tr>
-              <a:tr h="822960">
+              <a:tr h="830580">
                 <a:tc>
                   <a:txBody>
                     <a:bodyPr/>
                     <a:lstStyle/>
                     <a:p>
                       <a:pPr>
-                        <a:defRPr sz="950">
+                        <a:defRPr sz="900">
                           <a:solidFill>
                             <a:srgbClr val="0F172A"/>
                           </a:solidFill>
@@ -4884,14 +4903,14 @@
                     <a:lstStyle/>
                     <a:p>
                       <a:pPr>
-                        <a:defRPr sz="950" b="1">
+                        <a:defRPr sz="900" b="1">
                           <a:solidFill>
                             <a:srgbClr val="0F172A"/>
                           </a:solidFill>
                         </a:defRPr>
                       </a:pPr>
                       <a:r>
-                        <a:t>Find Your Path: Dynamic, customized week-by-week roadmaps (4-12 wks) with 100% free open-source resources</a:t>
+                        <a:t>Find Your Path: Dynamic week-by-week roadmaps (4-12 wks) with 100% free open-source resources &amp; milestone tracking</a:t>
                       </a:r>
                     </a:p>
                   </a:txBody>
@@ -4902,14 +4921,14 @@
                   </a:tcPr>
                 </a:tc>
               </a:tr>
-              <a:tr h="822960">
+              <a:tr h="830580">
                 <a:tc>
                   <a:txBody>
                     <a:bodyPr/>
                     <a:lstStyle/>
                     <a:p>
                       <a:pPr>
-                        <a:defRPr sz="950">
+                        <a:defRPr sz="900">
                           <a:solidFill>
                             <a:srgbClr val="0F172A"/>
                           </a:solidFill>
@@ -4932,14 +4951,14 @@
                     <a:lstStyle/>
                     <a:p>
                       <a:pPr>
-                        <a:defRPr sz="950" b="1">
+                        <a:defRPr sz="900" b="1">
                           <a:solidFill>
                             <a:srgbClr val="0F172A"/>
                           </a:solidFill>
                         </a:defRPr>
                       </a:pPr>
                       <a:r>
-                        <a:t>Learn From Past Selections: Branch-locked past successful resumes, candidate projects &amp; interview video rounds</a:t>
+                        <a:t>Learn From Past Selections: Branch-locked past successful resumes, candidate projects &amp; company interview video rounds</a:t>
                       </a:r>
                     </a:p>
                   </a:txBody>
@@ -4950,14 +4969,14 @@
                   </a:tcPr>
                 </a:tc>
               </a:tr>
-              <a:tr h="822960">
+              <a:tr h="830580">
                 <a:tc>
                   <a:txBody>
                     <a:bodyPr/>
                     <a:lstStyle/>
                     <a:p>
                       <a:pPr>
-                        <a:defRPr sz="950">
+                        <a:defRPr sz="900">
                           <a:solidFill>
                             <a:srgbClr val="0F172A"/>
                           </a:solidFill>
@@ -4980,7 +4999,7 @@
                     <a:lstStyle/>
                     <a:p>
                       <a:pPr>
-                        <a:defRPr sz="950" b="1">
+                        <a:defRPr sz="900" b="1">
                           <a:solidFill>
                             <a:srgbClr val="0F172A"/>
                           </a:solidFill>
@@ -4998,14 +5017,14 @@
                   </a:tcPr>
                 </a:tc>
               </a:tr>
-              <a:tr h="822960">
+              <a:tr h="830580">
                 <a:tc>
                   <a:txBody>
                     <a:bodyPr/>
                     <a:lstStyle/>
                     <a:p>
                       <a:pPr>
-                        <a:defRPr sz="950">
+                        <a:defRPr sz="900">
                           <a:solidFill>
                             <a:srgbClr val="0F172A"/>
                           </a:solidFill>
@@ -5028,7 +5047,7 @@
                     <a:lstStyle/>
                     <a:p>
                       <a:pPr>
-                        <a:defRPr sz="950" b="1">
+                        <a:defRPr sz="900" b="1">
                           <a:solidFill>
                             <a:srgbClr val="0F172A"/>
                           </a:solidFill>
@@ -5113,14 +5132,68 @@
       </p:sp>
       <p:sp>
         <p:nvSpPr>
-          <p:cNvPr id="3" name="TextBox 2"/>
+          <p:cNvPr id="3" name="Rounded Rectangle 2"/>
+          <p:cNvSpPr/>
+          <p:nvPr/>
+        </p:nvSpPr>
+        <p:spPr>
+          <a:xfrm>
+            <a:off x="731520" y="347472"/>
+            <a:ext cx="3840480" cy="256032"/>
+          </a:xfrm>
+          <a:prstGeom prst="roundRect">
+            <a:avLst/>
+          </a:prstGeom>
+          <a:solidFill>
+            <a:srgbClr val="FFF7ED"/>
+          </a:solidFill>
+          <a:ln w="12700">
+            <a:solidFill>
+              <a:srgbClr val="F97316"/>
+            </a:solidFill>
+          </a:ln>
+        </p:spPr>
+        <p:style>
+          <a:lnRef idx="1">
+            <a:schemeClr val="accent1"/>
+          </a:lnRef>
+          <a:fillRef idx="3">
+            <a:schemeClr val="accent1"/>
+          </a:fillRef>
+          <a:effectRef idx="2">
+            <a:schemeClr val="accent1"/>
+          </a:effectRef>
+          <a:fontRef idx="minor">
+            <a:schemeClr val="lt1"/>
+          </a:fontRef>
+        </p:style>
+        <p:txBody>
+          <a:bodyPr rtlCol="0" anchor="ctr" wrap="none"/>
+          <a:lstStyle/>
+          <a:p>
+            <a:pPr algn="ctr">
+              <a:defRPr sz="850" b="1">
+                <a:solidFill>
+                  <a:srgbClr val="F97316"/>
+                </a:solidFill>
+              </a:defRPr>
+            </a:pPr>
+            <a:r>
+              <a:t>RECRUITER-GRADE ATS PARSING &amp; DIAGNOSTICS</a:t>
+            </a:r>
+          </a:p>
+        </p:txBody>
+      </p:sp>
+      <p:sp>
+        <p:nvSpPr>
+          <p:cNvPr id="4" name="TextBox 3"/>
           <p:cNvSpPr txBox="1"/>
           <p:nvPr/>
         </p:nvSpPr>
         <p:spPr>
           <a:xfrm>
-            <a:off x="731520" y="365760"/>
-            <a:ext cx="10515600" cy="320040"/>
+            <a:off x="731520" y="640080"/>
+            <a:ext cx="10698480" cy="594360"/>
           </a:xfrm>
           <a:prstGeom prst="rect">
             <a:avLst/>
@@ -5134,42 +5207,7 @@
           <a:lstStyle/>
           <a:p>
             <a:pPr>
-              <a:defRPr sz="1000" b="1">
-                <a:solidFill>
-                  <a:srgbClr val="EA580C"/>
-                </a:solidFill>
-              </a:defRPr>
-            </a:pPr>
-            <a:r>
-              <a:t>DEEP RECRUITER AUDIT &amp; COMPLIANCE</a:t>
-            </a:r>
-          </a:p>
-        </p:txBody>
-      </p:sp>
-      <p:sp>
-        <p:nvSpPr>
-          <p:cNvPr id="4" name="TextBox 3"/>
-          <p:cNvSpPr txBox="1"/>
-          <p:nvPr/>
-        </p:nvSpPr>
-        <p:spPr>
-          <a:xfrm>
-            <a:off x="731520" y="658368"/>
-            <a:ext cx="10515600" cy="548640"/>
-          </a:xfrm>
-          <a:prstGeom prst="rect">
-            <a:avLst/>
-          </a:prstGeom>
-          <a:noFill/>
-        </p:spPr>
-        <p:txBody>
-          <a:bodyPr wrap="square">
-            <a:spAutoFit/>
-          </a:bodyPr>
-          <a:lstStyle/>
-          <a:p>
-            <a:pPr>
-              <a:defRPr sz="2200" b="1">
+              <a:defRPr sz="2100" b="1">
                 <a:solidFill>
                   <a:srgbClr val="0F172A"/>
                 </a:solidFill>
@@ -5190,7 +5228,7 @@
         <p:spPr>
           <a:xfrm>
             <a:off x="731520" y="1280160"/>
-            <a:ext cx="6400800" cy="5029200"/>
+            <a:ext cx="6217920" cy="5029200"/>
           </a:xfrm>
           <a:prstGeom prst="roundRect">
             <a:avLst/>
@@ -5223,19 +5261,19 @@
           <a:lstStyle/>
           <a:p>
             <a:pPr algn="ctr">
-              <a:defRPr sz="1300" b="1">
-                <a:solidFill>
-                  <a:srgbClr val="EA580C"/>
-                </a:solidFill>
-              </a:defRPr>
-            </a:pPr>
-            <a:r>
-              <a:t>In-Dashboard Recruiter Analysis Engine (6 Key Dimensions)</a:t>
-            </a:r>
-          </a:p>
-          <a:p>
-            <a:pPr>
-              <a:defRPr sz="1000" b="1">
+              <a:defRPr sz="1250" b="1">
+                <a:solidFill>
+                  <a:srgbClr val="F97316"/>
+                </a:solidFill>
+              </a:defRPr>
+            </a:pPr>
+            <a:r>
+              <a:t>In-Dashboard Recruiter Analysis Engine (6 Dimensions)</a:t>
+            </a:r>
+          </a:p>
+          <a:p>
+            <a:pPr>
+              <a:defRPr sz="950" b="1">
                 <a:solidFill>
                   <a:srgbClr val="0F172A"/>
                 </a:solidFill>
@@ -5247,19 +5285,19 @@
           </a:p>
           <a:p>
             <a:pPr>
-              <a:defRPr sz="900">
+              <a:defRPr sz="850">
                 <a:solidFill>
                   <a:srgbClr val="64748B"/>
                 </a:solidFill>
               </a:defRPr>
             </a:pPr>
             <a:r>
-              <a:t>Categorizes extracted tokens into Technical Skills, Engineering Frameworks (Git, Postman, Linux), and Soft/Analytical proficiencies.</a:t>
-            </a:r>
-          </a:p>
-          <a:p>
-            <a:pPr>
-              <a:defRPr sz="1000" b="1">
+              <a:t>Categorizes parsed tokens into Technical Skills, Engineering Frameworks (Git, Postman, Linux), and Soft/Analytical competencies. Auto-syncs to user profile.</a:t>
+            </a:r>
+          </a:p>
+          <a:p>
+            <a:pPr>
+              <a:defRPr sz="950" b="1">
                 <a:solidFill>
                   <a:srgbClr val="0F172A"/>
                 </a:solidFill>
@@ -5271,19 +5309,19 @@
           </a:p>
           <a:p>
             <a:pPr>
-              <a:defRPr sz="900">
+              <a:defRPr sz="850">
                 <a:solidFill>
                   <a:srgbClr val="64748B"/>
                 </a:solidFill>
               </a:defRPr>
             </a:pPr>
             <a:r>
-              <a:t>Evaluates layout hierarchy, single-column parsing, and provides a quantitative ATS Score (e.g., 94/100) with 1-page strict compliance.</a:t>
-            </a:r>
-          </a:p>
-          <a:p>
-            <a:pPr>
-              <a:defRPr sz="1000" b="1">
+              <a:t>Evaluates layout hierarchy, single-column parsing, and provides a quantitative ATS Score (e.g., 94/100) with 1-page strict compliance check.</a:t>
+            </a:r>
+          </a:p>
+          <a:p>
+            <a:pPr>
+              <a:defRPr sz="950" b="1">
                 <a:solidFill>
                   <a:srgbClr val="0F172A"/>
                 </a:solidFill>
@@ -5295,7 +5333,7 @@
           </a:p>
           <a:p>
             <a:pPr>
-              <a:defRPr sz="900">
+              <a:defRPr sz="850">
                 <a:solidFill>
                   <a:srgbClr val="64748B"/>
                 </a:solidFill>
@@ -5307,7 +5345,7 @@
           </a:p>
           <a:p>
             <a:pPr>
-              <a:defRPr sz="1000" b="1">
+              <a:defRPr sz="950" b="1">
                 <a:solidFill>
                   <a:srgbClr val="0F172A"/>
                 </a:solidFill>
@@ -5319,7 +5357,7 @@
           </a:p>
           <a:p>
             <a:pPr>
-              <a:defRPr sz="900">
+              <a:defRPr sz="850">
                 <a:solidFill>
                   <a:srgbClr val="64748B"/>
                 </a:solidFill>
@@ -5331,7 +5369,7 @@
           </a:p>
           <a:p>
             <a:pPr>
-              <a:defRPr sz="1000" b="1">
+              <a:defRPr sz="950" b="1">
                 <a:solidFill>
                   <a:srgbClr val="0F172A"/>
                 </a:solidFill>
@@ -5343,7 +5381,7 @@
           </a:p>
           <a:p>
             <a:pPr>
-              <a:defRPr sz="900">
+              <a:defRPr sz="850">
                 <a:solidFill>
                   <a:srgbClr val="64748B"/>
                 </a:solidFill>
@@ -5355,7 +5393,7 @@
           </a:p>
           <a:p>
             <a:pPr>
-              <a:defRPr sz="1000" b="1">
+              <a:defRPr sz="950" b="1">
                 <a:solidFill>
                   <a:srgbClr val="0F172A"/>
                 </a:solidFill>
@@ -5367,7 +5405,7 @@
           </a:p>
           <a:p>
             <a:pPr>
-              <a:defRPr sz="900">
+              <a:defRPr sz="850">
                 <a:solidFill>
                   <a:srgbClr val="64748B"/>
                 </a:solidFill>
@@ -5381,7 +5419,7 @@
       </p:sp>
       <p:pic>
         <p:nvPicPr>
-          <p:cNvPr id="6" name="Picture 5" descr="resume_analyzer_mockup.png"/>
+          <p:cNvPr id="6" name="Picture 5" descr="resume_analyzer_pro.png"/>
           <p:cNvPicPr>
             <a:picLocks noChangeAspect="1"/>
           </p:cNvPicPr>
@@ -5395,8 +5433,8 @@
         </p:blipFill>
         <p:spPr>
           <a:xfrm>
-            <a:off x="7406640" y="1280160"/>
-            <a:ext cx="4023360" cy="3665546"/>
+            <a:off x="7132320" y="1280160"/>
+            <a:ext cx="4297680" cy="4100009"/>
           </a:xfrm>
           <a:prstGeom prst="rect">
             <a:avLst/>
@@ -5466,14 +5504,68 @@
       </p:sp>
       <p:sp>
         <p:nvSpPr>
-          <p:cNvPr id="3" name="TextBox 2"/>
+          <p:cNvPr id="3" name="Rounded Rectangle 2"/>
+          <p:cNvSpPr/>
+          <p:nvPr/>
+        </p:nvSpPr>
+        <p:spPr>
+          <a:xfrm>
+            <a:off x="731520" y="347472"/>
+            <a:ext cx="3840480" cy="256032"/>
+          </a:xfrm>
+          <a:prstGeom prst="roundRect">
+            <a:avLst/>
+          </a:prstGeom>
+          <a:solidFill>
+            <a:srgbClr val="FFF7ED"/>
+          </a:solidFill>
+          <a:ln w="12700">
+            <a:solidFill>
+              <a:srgbClr val="F97316"/>
+            </a:solidFill>
+          </a:ln>
+        </p:spPr>
+        <p:style>
+          <a:lnRef idx="1">
+            <a:schemeClr val="accent1"/>
+          </a:lnRef>
+          <a:fillRef idx="3">
+            <a:schemeClr val="accent1"/>
+          </a:fillRef>
+          <a:effectRef idx="2">
+            <a:schemeClr val="accent1"/>
+          </a:effectRef>
+          <a:fontRef idx="minor">
+            <a:schemeClr val="lt1"/>
+          </a:fontRef>
+        </p:style>
+        <p:txBody>
+          <a:bodyPr rtlCol="0" anchor="ctr" wrap="none"/>
+          <a:lstStyle/>
+          <a:p>
+            <a:pPr algn="ctr">
+              <a:defRPr sz="850" b="1">
+                <a:solidFill>
+                  <a:srgbClr val="F97316"/>
+                </a:solidFill>
+              </a:defRPr>
+            </a:pPr>
+            <a:r>
+              <a:t>STRATEGIC PREPARATION &amp; OPPORTUNITY AWARENESS</a:t>
+            </a:r>
+          </a:p>
+        </p:txBody>
+      </p:sp>
+      <p:sp>
+        <p:nvSpPr>
+          <p:cNvPr id="4" name="TextBox 3"/>
           <p:cNvSpPr txBox="1"/>
           <p:nvPr/>
         </p:nvSpPr>
         <p:spPr>
           <a:xfrm>
-            <a:off x="731520" y="365760"/>
-            <a:ext cx="10515600" cy="320040"/>
+            <a:off x="731520" y="640080"/>
+            <a:ext cx="10698480" cy="594360"/>
           </a:xfrm>
           <a:prstGeom prst="rect">
             <a:avLst/>
@@ -5487,49 +5579,14 @@
           <a:lstStyle/>
           <a:p>
             <a:pPr>
-              <a:defRPr sz="1000" b="1">
-                <a:solidFill>
-                  <a:srgbClr val="EA580C"/>
-                </a:solidFill>
-              </a:defRPr>
-            </a:pPr>
-            <a:r>
-              <a:t>STRATEGIC PREPARATION &amp; OPPORTUNITY AWARENESS</a:t>
-            </a:r>
-          </a:p>
-        </p:txBody>
-      </p:sp>
-      <p:sp>
-        <p:nvSpPr>
-          <p:cNvPr id="4" name="TextBox 3"/>
-          <p:cNvSpPr txBox="1"/>
-          <p:nvPr/>
-        </p:nvSpPr>
-        <p:spPr>
-          <a:xfrm>
-            <a:off x="731520" y="658368"/>
-            <a:ext cx="10515600" cy="548640"/>
-          </a:xfrm>
-          <a:prstGeom prst="rect">
-            <a:avLst/>
-          </a:prstGeom>
-          <a:noFill/>
-        </p:spPr>
-        <p:txBody>
-          <a:bodyPr wrap="square">
-            <a:spAutoFit/>
-          </a:bodyPr>
-          <a:lstStyle/>
-          <a:p>
-            <a:pPr>
-              <a:defRPr sz="2200" b="1">
+              <a:defRPr sz="2100" b="1">
                 <a:solidFill>
                   <a:srgbClr val="0F172A"/>
                 </a:solidFill>
               </a:defRPr>
             </a:pPr>
             <a:r>
-              <a:t>Core Feature 2: Personalized Career Roadmaps &amp; Job Creation News</a:t>
+              <a:t>Core Feature 2: Personalized Career Roadmaps &amp; Corporate Hiring News</a:t>
             </a:r>
           </a:p>
         </p:txBody>
@@ -5542,8 +5599,8 @@
         </p:nvSpPr>
         <p:spPr>
           <a:xfrm>
-            <a:off x="731520" y="1325880"/>
-            <a:ext cx="5212080" cy="4937760"/>
+            <a:off x="731520" y="1280160"/>
+            <a:ext cx="4754880" cy="5029200"/>
           </a:xfrm>
           <a:prstGeom prst="roundRect">
             <a:avLst/>
@@ -5576,9 +5633,21 @@
           <a:lstStyle/>
           <a:p>
             <a:pPr algn="ctr">
-              <a:defRPr sz="1300" b="1">
-                <a:solidFill>
-                  <a:srgbClr val="4F46E5"/>
+              <a:defRPr sz="1250" b="1">
+                <a:solidFill>
+                  <a:srgbClr val="6366F1"/>
+                </a:solidFill>
+              </a:defRPr>
+            </a:pPr>
+            <a:r>
+              <a:t>Strategic Career Direction &amp; Opportunity Stream</a:t>
+            </a:r>
+          </a:p>
+          <a:p>
+            <a:pPr>
+              <a:defRPr sz="1050" b="1">
+                <a:solidFill>
+                  <a:srgbClr val="6366F1"/>
                 </a:solidFill>
               </a:defRPr>
             </a:pPr>
@@ -5588,7 +5657,7 @@
           </a:p>
           <a:p>
             <a:pPr>
-              <a:defRPr sz="1000" b="1">
+              <a:defRPr sz="900" b="1">
                 <a:solidFill>
                   <a:srgbClr val="0F172A"/>
                 </a:solidFill>
@@ -5600,19 +5669,19 @@
           </a:p>
           <a:p>
             <a:pPr>
-              <a:defRPr sz="900">
+              <a:defRPr sz="819">
                 <a:solidFill>
                   <a:srgbClr val="64748B"/>
                 </a:solidFill>
               </a:defRPr>
             </a:pPr>
             <a:r>
-              <a:t>Student selects their dream role from official PMIS tracks or searches custom domains (VLSI, Full Stack, Data Science, Automotive).</a:t>
-            </a:r>
-          </a:p>
-          <a:p>
-            <a:pPr>
-              <a:defRPr sz="1000" b="1">
+              <a:t>Select dream role from official PMIS tracks or search custom fields (VLSI, Full Stack, Data Science, Automotive).</a:t>
+            </a:r>
+          </a:p>
+          <a:p>
+            <a:pPr>
+              <a:defRPr sz="900" b="1">
                 <a:solidFill>
                   <a:srgbClr val="0F172A"/>
                 </a:solidFill>
@@ -5624,264 +5693,150 @@
           </a:p>
           <a:p>
             <a:pPr>
-              <a:defRPr sz="900">
+              <a:defRPr sz="819">
                 <a:solidFill>
                   <a:srgbClr val="64748B"/>
                 </a:solidFill>
               </a:defRPr>
             </a:pPr>
             <a:r>
-              <a:t>Customizable preparation windows (4 Weeks Fast-Track, 8 Weeks Balanced, 12 Weeks Mastery) tailored to candidate's available study bandwidth.</a:t>
-            </a:r>
-          </a:p>
-          <a:p>
-            <a:pPr>
-              <a:defRPr sz="1000" b="1">
+              <a:t>Customizable duration (4 Weeks Fast-Track, 8 Weeks Balanced, 12 Weeks Mastery) matching candidate bandwidth.</a:t>
+            </a:r>
+          </a:p>
+          <a:p>
+            <a:pPr>
+              <a:defRPr sz="900" b="1">
                 <a:solidFill>
                   <a:srgbClr val="0F172A"/>
                 </a:solidFill>
               </a:defRPr>
             </a:pPr>
             <a:r>
-              <a:t>• Structured Weekly Syllabus:</a:t>
-            </a:r>
-          </a:p>
-          <a:p>
-            <a:pPr>
-              <a:defRPr sz="900">
+              <a:t>• 100% Free &amp; Open-Source Resources:</a:t>
+            </a:r>
+          </a:p>
+          <a:p>
+            <a:pPr>
+              <a:defRPr sz="819">
                 <a:solidFill>
                   <a:srgbClr val="64748B"/>
                 </a:solidFill>
               </a:defRPr>
             </a:pPr>
             <a:r>
-              <a:t>Breaks learning into Week 1 (Core Foundations), Week 2 (Hands-on Projects), Week 3 (Frameworks), and Week 4 (Mock Interviews &amp; PMIS Submission).</a:t>
-            </a:r>
-          </a:p>
-          <a:p>
-            <a:pPr>
-              <a:defRPr sz="1000" b="1">
+              <a:t>Zero paywalls; direct links to curated GitHub repositories, official documentation, MIT/Stanford OpenCourseWare, and free interactive labs.</a:t>
+            </a:r>
+          </a:p>
+          <a:p>
+            <a:pPr>
+              <a:defRPr sz="1050" b="1">
+                <a:solidFill>
+                  <a:srgbClr val="F97316"/>
+                </a:solidFill>
+              </a:defRPr>
+            </a:pPr>
+            <a:r>
+              <a:t>2. 'Don't Fall in the Trap' — Corporate Hiring Stream</a:t>
+            </a:r>
+          </a:p>
+          <a:p>
+            <a:pPr>
+              <a:defRPr sz="900" b="1">
                 <a:solidFill>
                   <a:srgbClr val="0F172A"/>
                 </a:solidFill>
               </a:defRPr>
             </a:pPr>
             <a:r>
-              <a:t>• 100% Free &amp; Open-Source Resources:</a:t>
-            </a:r>
-          </a:p>
-          <a:p>
-            <a:pPr>
-              <a:defRPr sz="900">
+              <a:t>• Countering 2026-30 Layoff Panic:</a:t>
+            </a:r>
+          </a:p>
+          <a:p>
+            <a:pPr>
+              <a:defRPr sz="819">
                 <a:solidFill>
                   <a:srgbClr val="64748B"/>
                 </a:solidFill>
               </a:defRPr>
             </a:pPr>
             <a:r>
-              <a:t>Direct links to curated GitHub repositories, official documentation, MIT/Stanford OpenCourseWare, and free interactive practice labs.</a:t>
-            </a:r>
-          </a:p>
-          <a:p>
-            <a:pPr>
-              <a:defRPr sz="1000" b="1">
+              <a:t>Replaces anxiety with facts by highlighting positive job creation announcements occurring every single day across India.</a:t>
+            </a:r>
+          </a:p>
+          <a:p>
+            <a:pPr>
+              <a:defRPr sz="900" b="1">
                 <a:solidFill>
                   <a:srgbClr val="0F172A"/>
                 </a:solidFill>
               </a:defRPr>
             </a:pPr>
             <a:r>
-              <a:t>• Interactive Progress Tracking:</a:t>
-            </a:r>
-          </a:p>
-          <a:p>
-            <a:pPr>
-              <a:defRPr sz="900">
+              <a:t>• Multi-Source Daily Ingestion:</a:t>
+            </a:r>
+          </a:p>
+          <a:p>
+            <a:pPr>
+              <a:defRPr sz="819">
                 <a:solidFill>
                   <a:srgbClr val="64748B"/>
                 </a:solidFill>
               </a:defRPr>
             </a:pPr>
             <a:r>
-              <a:t>Checkable weekly milestones stored in student profile to ensure continuous accountability.</a:t>
-            </a:r>
-          </a:p>
-        </p:txBody>
-      </p:sp>
-      <p:sp>
-        <p:nvSpPr>
-          <p:cNvPr id="6" name="Rounded Rectangle 5"/>
-          <p:cNvSpPr/>
+              <a:t>Aggregates announcements from Google News, corporate press releases, Economic Times, and MNC expansion portals with 1-click source verification.</a:t>
+            </a:r>
+          </a:p>
+          <a:p>
+            <a:pPr>
+              <a:defRPr sz="900" b="1">
+                <a:solidFill>
+                  <a:srgbClr val="0F172A"/>
+                </a:solidFill>
+              </a:defRPr>
+            </a:pPr>
+            <a:r>
+              <a:t>• Direct Corporate Application Link:</a:t>
+            </a:r>
+          </a:p>
+          <a:p>
+            <a:pPr>
+              <a:defRPr sz="819">
+                <a:solidFill>
+                  <a:srgbClr val="64748B"/>
+                </a:solidFill>
+              </a:defRPr>
+            </a:pPr>
+            <a:r>
+              <a:t>Connects real corporate announcements directly to matching PMIS internship application portals.</a:t>
+            </a:r>
+          </a:p>
+        </p:txBody>
+      </p:sp>
+      <p:pic>
+        <p:nvPicPr>
+          <p:cNvPr id="6" name="Picture 5" descr="roadmap_news_combo.png"/>
+          <p:cNvPicPr>
+            <a:picLocks noChangeAspect="1"/>
+          </p:cNvPicPr>
           <p:nvPr/>
-        </p:nvSpPr>
+        </p:nvPicPr>
+        <p:blipFill>
+          <a:blip r:embed="rId2"/>
+          <a:stretch>
+            <a:fillRect/>
+          </a:stretch>
+        </p:blipFill>
         <p:spPr>
           <a:xfrm>
-            <a:off x="6217920" y="1325880"/>
-            <a:ext cx="5212080" cy="4937760"/>
+            <a:off x="5669280" y="1280160"/>
+            <a:ext cx="5760720" cy="2386717"/>
           </a:xfrm>
-          <a:prstGeom prst="roundRect">
+          <a:prstGeom prst="rect">
             <a:avLst/>
           </a:prstGeom>
-          <a:solidFill>
-            <a:srgbClr val="FFFFFF"/>
-          </a:solidFill>
-          <a:ln w="19050">
-            <a:solidFill>
-              <a:srgbClr val="E2E8F0"/>
-            </a:solidFill>
-          </a:ln>
         </p:spPr>
-        <p:style>
-          <a:lnRef idx="1">
-            <a:schemeClr val="accent1"/>
-          </a:lnRef>
-          <a:fillRef idx="3">
-            <a:schemeClr val="accent1"/>
-          </a:fillRef>
-          <a:effectRef idx="2">
-            <a:schemeClr val="accent1"/>
-          </a:effectRef>
-          <a:fontRef idx="minor">
-            <a:schemeClr val="lt1"/>
-          </a:fontRef>
-        </p:style>
-        <p:txBody>
-          <a:bodyPr rtlCol="0" anchor="ctr" wrap="square"/>
-          <a:lstStyle/>
-          <a:p>
-            <a:pPr algn="ctr">
-              <a:defRPr sz="1300" b="1">
-                <a:solidFill>
-                  <a:srgbClr val="EA580C"/>
-                </a:solidFill>
-              </a:defRPr>
-            </a:pPr>
-            <a:r>
-              <a:t>2. 'Don't Fall in the Trap' — Daily Corporate Hiring Stream</a:t>
-            </a:r>
-          </a:p>
-          <a:p>
-            <a:pPr>
-              <a:defRPr sz="1000" b="1">
-                <a:solidFill>
-                  <a:srgbClr val="0F172A"/>
-                </a:solidFill>
-              </a:defRPr>
-            </a:pPr>
-            <a:r>
-              <a:t>• Combating 2026-30 Layoff Depression:</a:t>
-            </a:r>
-          </a:p>
-          <a:p>
-            <a:pPr>
-              <a:defRPr sz="900">
-                <a:solidFill>
-                  <a:srgbClr val="64748B"/>
-                </a:solidFill>
-              </a:defRPr>
-            </a:pPr>
-            <a:r>
-              <a:t>Viral media highlights layoffs and freezes, triggering student panic. This module proves that massive hiring continues daily across core sectors.</a:t>
-            </a:r>
-          </a:p>
-          <a:p>
-            <a:pPr>
-              <a:defRPr sz="1000" b="1">
-                <a:solidFill>
-                  <a:srgbClr val="0F172A"/>
-                </a:solidFill>
-              </a:defRPr>
-            </a:pPr>
-            <a:r>
-              <a:t>• Daily Multi-Source Ingestion:</a:t>
-            </a:r>
-          </a:p>
-          <a:p>
-            <a:pPr>
-              <a:defRPr sz="900">
-                <a:solidFill>
-                  <a:srgbClr val="64748B"/>
-                </a:solidFill>
-              </a:defRPr>
-            </a:pPr>
-            <a:r>
-              <a:t>Aggregates verified corporate job creation announcements from Google News, corporate press releases, Economic Times, and MNC expansion portals.</a:t>
-            </a:r>
-          </a:p>
-          <a:p>
-            <a:pPr>
-              <a:defRPr sz="1000" b="1">
-                <a:solidFill>
-                  <a:srgbClr val="0F172A"/>
-                </a:solidFill>
-              </a:defRPr>
-            </a:pPr>
-            <a:r>
-              <a:t>• Focus on Real Opportunity Creation:</a:t>
-            </a:r>
-          </a:p>
-          <a:p>
-            <a:pPr>
-              <a:defRPr sz="900">
-                <a:solidFill>
-                  <a:srgbClr val="64748B"/>
-                </a:solidFill>
-              </a:defRPr>
-            </a:pPr>
-            <a:r>
-              <a:t>Surfaces new GCC investments, green hydrogen plants, semiconductor fabrication units, automotive tech hubs, and corporate expansion drives.</a:t>
-            </a:r>
-          </a:p>
-          <a:p>
-            <a:pPr>
-              <a:defRPr sz="1000" b="1">
-                <a:solidFill>
-                  <a:srgbClr val="0F172A"/>
-                </a:solidFill>
-              </a:defRPr>
-            </a:pPr>
-            <a:r>
-              <a:t>• Transparent Source Links &amp; Dates:</a:t>
-            </a:r>
-          </a:p>
-          <a:p>
-            <a:pPr>
-              <a:defRPr sz="900">
-                <a:solidFill>
-                  <a:srgbClr val="64748B"/>
-                </a:solidFill>
-              </a:defRPr>
-            </a:pPr>
-            <a:r>
-              <a:t>Every opportunity card provides transparent timestamps, company tags, and 1-click external source verification links.</a:t>
-            </a:r>
-          </a:p>
-          <a:p>
-            <a:pPr>
-              <a:defRPr sz="1000" b="1">
-                <a:solidFill>
-                  <a:srgbClr val="0F172A"/>
-                </a:solidFill>
-              </a:defRPr>
-            </a:pPr>
-            <a:r>
-              <a:t>• Accessible from Home (Login-Protected):</a:t>
-            </a:r>
-          </a:p>
-          <a:p>
-            <a:pPr>
-              <a:defRPr sz="900">
-                <a:solidFill>
-                  <a:srgbClr val="64748B"/>
-                </a:solidFill>
-              </a:defRPr>
-            </a:pPr>
-            <a:r>
-              <a:t>Keeps student dashboard focused on active tasks, while allowing explore-mode for all registered candidates.</a:t>
-            </a:r>
-          </a:p>
-        </p:txBody>
-      </p:sp>
+      </p:pic>
     </p:spTree>
   </p:cSld>
   <p:clrMapOvr>
@@ -5945,14 +5900,68 @@
       </p:sp>
       <p:sp>
         <p:nvSpPr>
-          <p:cNvPr id="3" name="TextBox 2"/>
+          <p:cNvPr id="3" name="Rounded Rectangle 2"/>
+          <p:cNvSpPr/>
+          <p:nvPr/>
+        </p:nvSpPr>
+        <p:spPr>
+          <a:xfrm>
+            <a:off x="731520" y="347472"/>
+            <a:ext cx="3840480" cy="256032"/>
+          </a:xfrm>
+          <a:prstGeom prst="roundRect">
+            <a:avLst/>
+          </a:prstGeom>
+          <a:solidFill>
+            <a:srgbClr val="FFF7ED"/>
+          </a:solidFill>
+          <a:ln w="12700">
+            <a:solidFill>
+              <a:srgbClr val="F97316"/>
+            </a:solidFill>
+          </a:ln>
+        </p:spPr>
+        <p:style>
+          <a:lnRef idx="1">
+            <a:schemeClr val="accent1"/>
+          </a:lnRef>
+          <a:fillRef idx="3">
+            <a:schemeClr val="accent1"/>
+          </a:fillRef>
+          <a:effectRef idx="2">
+            <a:schemeClr val="accent1"/>
+          </a:effectRef>
+          <a:fontRef idx="minor">
+            <a:schemeClr val="lt1"/>
+          </a:fontRef>
+        </p:style>
+        <p:txBody>
+          <a:bodyPr rtlCol="0" anchor="ctr" wrap="none"/>
+          <a:lstStyle/>
+          <a:p>
+            <a:pPr algn="ctr">
+              <a:defRPr sz="850" b="1">
+                <a:solidFill>
+                  <a:srgbClr val="F97316"/>
+                </a:solidFill>
+              </a:defRPr>
+            </a:pPr>
+            <a:r>
+              <a:t>INTELLIGENT BENCHMARKING &amp; CONVERSATIONAL ASSISTANCE</a:t>
+            </a:r>
+          </a:p>
+        </p:txBody>
+      </p:sp>
+      <p:sp>
+        <p:nvSpPr>
+          <p:cNvPr id="4" name="TextBox 3"/>
           <p:cNvSpPr txBox="1"/>
           <p:nvPr/>
         </p:nvSpPr>
         <p:spPr>
           <a:xfrm>
-            <a:off x="731520" y="365760"/>
-            <a:ext cx="10515600" cy="320040"/>
+            <a:off x="731520" y="640080"/>
+            <a:ext cx="10698480" cy="594360"/>
           </a:xfrm>
           <a:prstGeom prst="rect">
             <a:avLst/>
@@ -5966,49 +5975,14 @@
           <a:lstStyle/>
           <a:p>
             <a:pPr>
-              <a:defRPr sz="1000" b="1">
-                <a:solidFill>
-                  <a:srgbClr val="EA580C"/>
-                </a:solidFill>
-              </a:defRPr>
-            </a:pPr>
-            <a:r>
-              <a:t>INTELLIGENT BENCHMARKING &amp; CONVERSATIONAL ASSISTANCE</a:t>
-            </a:r>
-          </a:p>
-        </p:txBody>
-      </p:sp>
-      <p:sp>
-        <p:nvSpPr>
-          <p:cNvPr id="4" name="TextBox 3"/>
-          <p:cNvSpPr txBox="1"/>
-          <p:nvPr/>
-        </p:nvSpPr>
-        <p:spPr>
-          <a:xfrm>
-            <a:off x="731520" y="658368"/>
-            <a:ext cx="10515600" cy="548640"/>
-          </a:xfrm>
-          <a:prstGeom prst="rect">
-            <a:avLst/>
-          </a:prstGeom>
-          <a:noFill/>
-        </p:spPr>
-        <p:txBody>
-          <a:bodyPr wrap="square">
-            <a:spAutoFit/>
-          </a:bodyPr>
-          <a:lstStyle/>
-          <a:p>
-            <a:pPr>
-              <a:defRPr sz="2200" b="1">
+              <a:defRPr sz="2100" b="1">
                 <a:solidFill>
                   <a:srgbClr val="0F172A"/>
                 </a:solidFill>
               </a:defRPr>
             </a:pPr>
             <a:r>
-              <a:t>Core Feature 3: Hiring Transparency, Gap Diagnostics &amp; Disha AI</a:t>
+              <a:t>Core Feature 3: Hiring Transparency, Skill Gap Diagnostics &amp; Disha AI</a:t>
             </a:r>
           </a:p>
         </p:txBody>
@@ -6021,8 +5995,8 @@
         </p:nvSpPr>
         <p:spPr>
           <a:xfrm>
-            <a:off x="731520" y="1325880"/>
-            <a:ext cx="3401568" cy="4937760"/>
+            <a:off x="731520" y="1280160"/>
+            <a:ext cx="4754880" cy="5029200"/>
           </a:xfrm>
           <a:prstGeom prst="roundRect">
             <a:avLst/>
@@ -6055,342 +6029,222 @@
           <a:lstStyle/>
           <a:p>
             <a:pPr algn="ctr">
-              <a:defRPr sz="1300" b="1">
+              <a:defRPr sz="1250" b="1">
                 <a:solidFill>
                   <a:srgbClr val="10B981"/>
                 </a:solidFill>
               </a:defRPr>
             </a:pPr>
             <a:r>
-              <a:t>Learn From Past Selections</a:t>
-            </a:r>
-          </a:p>
-          <a:p>
-            <a:pPr>
-              <a:defRPr sz="1000" b="1">
+              <a:t>Transparency, Diagnostics &amp; Conversational AI</a:t>
+            </a:r>
+          </a:p>
+          <a:p>
+            <a:pPr>
+              <a:defRPr sz="1050" b="1">
+                <a:solidFill>
+                  <a:srgbClr val="10B981"/>
+                </a:solidFill>
+              </a:defRPr>
+            </a:pPr>
+            <a:r>
+              <a:t>1. Learn From Past Selections (Branch-Locked)</a:t>
+            </a:r>
+          </a:p>
+          <a:p>
+            <a:pPr>
+              <a:defRPr sz="900" b="1">
                 <a:solidFill>
                   <a:srgbClr val="0F172A"/>
                 </a:solidFill>
               </a:defRPr>
             </a:pPr>
             <a:r>
-              <a:t>Branch-Locked Insights:</a:t>
-            </a:r>
-          </a:p>
-          <a:p>
-            <a:pPr>
-              <a:defRPr sz="900">
+              <a:t>• Discipline-Specific Blueprints:</a:t>
+            </a:r>
+          </a:p>
+          <a:p>
+            <a:pPr>
+              <a:defRPr sz="819">
                 <a:solidFill>
                   <a:srgbClr val="64748B"/>
                 </a:solidFill>
               </a:defRPr>
             </a:pPr>
             <a:r>
-              <a:t>Locked to candidate's discipline (CS/IT, Mech, Civil, Electrical, Mgmt) so insights are strictly relevant.</a:t>
-            </a:r>
-          </a:p>
-          <a:p>
-            <a:pPr>
-              <a:defRPr sz="1000" b="1">
+              <a:t>Strictly locked to candidate's branch (CS/IT, Mech, Civil, Electrical, Mgmt) so advice is 100% relevant.</a:t>
+            </a:r>
+          </a:p>
+          <a:p>
+            <a:pPr>
+              <a:defRPr sz="900" b="1">
                 <a:solidFill>
                   <a:srgbClr val="0F172A"/>
                 </a:solidFill>
               </a:defRPr>
             </a:pPr>
             <a:r>
-              <a:t>Raw Resume Blueprint:</a:t>
-            </a:r>
-          </a:p>
-          <a:p>
-            <a:pPr>
-              <a:defRPr sz="900">
+              <a:t>• Real Winning Projects:</a:t>
+            </a:r>
+          </a:p>
+          <a:p>
+            <a:pPr>
+              <a:defRPr sz="819">
                 <a:solidFill>
                   <a:srgbClr val="64748B"/>
                 </a:solidFill>
               </a:defRPr>
             </a:pPr>
             <a:r>
-              <a:t>Examines past selected candidates' real project structures, technical skills, and layout formats.</a:t>
-            </a:r>
-          </a:p>
-          <a:p>
-            <a:pPr>
-              <a:defRPr sz="1000" b="1">
+              <a:t>Examines anonymized profiles of students previously selected by top corporations, their project architectures, and tools.</a:t>
+            </a:r>
+          </a:p>
+          <a:p>
+            <a:pPr>
+              <a:defRPr sz="900" b="1">
                 <a:solidFill>
                   <a:srgbClr val="0F172A"/>
                 </a:solidFill>
               </a:defRPr>
             </a:pPr>
             <a:r>
-              <a:t>Company Interview Videos:</a:t>
-            </a:r>
-          </a:p>
-          <a:p>
-            <a:pPr>
-              <a:defRPr sz="900">
+              <a:t>• Company Interview Videos:</a:t>
+            </a:r>
+          </a:p>
+          <a:p>
+            <a:pPr>
+              <a:defRPr sz="819">
                 <a:solidFill>
                   <a:srgbClr val="64748B"/>
                 </a:solidFill>
               </a:defRPr>
             </a:pPr>
             <a:r>
-              <a:t>Curated video breakdowns of technical coding, design rounds, and HR interviews provided for each branch.</a:t>
-            </a:r>
-          </a:p>
-        </p:txBody>
-      </p:sp>
-      <p:sp>
-        <p:nvSpPr>
-          <p:cNvPr id="6" name="Rounded Rectangle 5"/>
-          <p:cNvSpPr/>
+              <a:t>Curated video breakdowns of technical coding tests, machine rounds, and HR interview round preparation.</a:t>
+            </a:r>
+          </a:p>
+          <a:p>
+            <a:pPr>
+              <a:defRPr sz="1050" b="1">
+                <a:solidFill>
+                  <a:srgbClr val="F97316"/>
+                </a:solidFill>
+              </a:defRPr>
+            </a:pPr>
+            <a:r>
+              <a:t>2. Find the Gap (Real-Time Diagnostics)</a:t>
+            </a:r>
+          </a:p>
+          <a:p>
+            <a:pPr>
+              <a:defRPr sz="900" b="1">
+                <a:solidFill>
+                  <a:srgbClr val="0F172A"/>
+                </a:solidFill>
+              </a:defRPr>
+            </a:pPr>
+            <a:r>
+              <a:t>• Match Verdict:</a:t>
+            </a:r>
+          </a:p>
+          <a:p>
+            <a:pPr>
+              <a:defRPr sz="819">
+                <a:solidFill>
+                  <a:srgbClr val="64748B"/>
+                </a:solidFill>
+              </a:defRPr>
+            </a:pPr>
+            <a:r>
+              <a:t>Compares resume skills vs. corporate opening criteria, delivering instant verdict (Strong Match vs. Action Needed).</a:t>
+            </a:r>
+          </a:p>
+          <a:p>
+            <a:pPr>
+              <a:defRPr sz="900" b="1">
+                <a:solidFill>
+                  <a:srgbClr val="0F172A"/>
+                </a:solidFill>
+              </a:defRPr>
+            </a:pPr>
+            <a:r>
+              <a:t>• 1-Click Learning Addition:</a:t>
+            </a:r>
+          </a:p>
+          <a:p>
+            <a:pPr>
+              <a:defRPr sz="819">
+                <a:solidFill>
+                  <a:srgbClr val="64748B"/>
+                </a:solidFill>
+              </a:defRPr>
+            </a:pPr>
+            <a:r>
+              <a:t>Flags missing competencies and adds them directly into the student's active roadmap.</a:t>
+            </a:r>
+          </a:p>
+          <a:p>
+            <a:pPr>
+              <a:defRPr sz="1050" b="1">
+                <a:solidFill>
+                  <a:srgbClr val="0EA5E9"/>
+                </a:solidFill>
+              </a:defRPr>
+            </a:pPr>
+            <a:r>
+              <a:t>3. Disha AI Guide (24/7 Grounded Chatbot)</a:t>
+            </a:r>
+          </a:p>
+          <a:p>
+            <a:pPr>
+              <a:defRPr sz="900" b="1">
+                <a:solidFill>
+                  <a:srgbClr val="0F172A"/>
+                </a:solidFill>
+              </a:defRPr>
+            </a:pPr>
+            <a:r>
+              <a:t>• Hybrid RAG Architecture:</a:t>
+            </a:r>
+          </a:p>
+          <a:p>
+            <a:pPr>
+              <a:defRPr sz="819">
+                <a:solidFill>
+                  <a:srgbClr val="64748B"/>
+                </a:solidFill>
+              </a:defRPr>
+            </a:pPr>
+            <a:r>
+              <a:t>Grounded in official scheme data to answer questions on stipend rules (₹5k/mo + ₹6k grant), eligibility, and sector openings without hallucinations.</a:t>
+            </a:r>
+          </a:p>
+        </p:txBody>
+      </p:sp>
+      <p:pic>
+        <p:nvPicPr>
+          <p:cNvPr id="6" name="Picture 5" descr="past_selections_gap.png"/>
+          <p:cNvPicPr>
+            <a:picLocks noChangeAspect="1"/>
+          </p:cNvPicPr>
           <p:nvPr/>
-        </p:nvSpPr>
+        </p:nvPicPr>
+        <p:blipFill>
+          <a:blip r:embed="rId2"/>
+          <a:stretch>
+            <a:fillRect/>
+          </a:stretch>
+        </p:blipFill>
         <p:spPr>
           <a:xfrm>
-            <a:off x="4389120" y="1325880"/>
-            <a:ext cx="3401568" cy="4937760"/>
+            <a:off x="5669280" y="1280160"/>
+            <a:ext cx="5760720" cy="2386717"/>
           </a:xfrm>
-          <a:prstGeom prst="roundRect">
+          <a:prstGeom prst="rect">
             <a:avLst/>
           </a:prstGeom>
-          <a:solidFill>
-            <a:srgbClr val="FFFFFF"/>
-          </a:solidFill>
-          <a:ln w="19050">
-            <a:solidFill>
-              <a:srgbClr val="E2E8F0"/>
-            </a:solidFill>
-          </a:ln>
         </p:spPr>
-        <p:style>
-          <a:lnRef idx="1">
-            <a:schemeClr val="accent1"/>
-          </a:lnRef>
-          <a:fillRef idx="3">
-            <a:schemeClr val="accent1"/>
-          </a:fillRef>
-          <a:effectRef idx="2">
-            <a:schemeClr val="accent1"/>
-          </a:effectRef>
-          <a:fontRef idx="minor">
-            <a:schemeClr val="lt1"/>
-          </a:fontRef>
-        </p:style>
-        <p:txBody>
-          <a:bodyPr rtlCol="0" anchor="ctr" wrap="square"/>
-          <a:lstStyle/>
-          <a:p>
-            <a:pPr algn="ctr">
-              <a:defRPr sz="1300" b="1">
-                <a:solidFill>
-                  <a:srgbClr val="EA580C"/>
-                </a:solidFill>
-              </a:defRPr>
-            </a:pPr>
-            <a:r>
-              <a:t>Find the Gap (Diagnostics)</a:t>
-            </a:r>
-          </a:p>
-          <a:p>
-            <a:pPr>
-              <a:defRPr sz="1000" b="1">
-                <a:solidFill>
-                  <a:srgbClr val="0F172A"/>
-                </a:solidFill>
-              </a:defRPr>
-            </a:pPr>
-            <a:r>
-              <a:t>Target Role Matchup:</a:t>
-            </a:r>
-          </a:p>
-          <a:p>
-            <a:pPr>
-              <a:defRPr sz="900">
-                <a:solidFill>
-                  <a:srgbClr val="64748B"/>
-                </a:solidFill>
-              </a:defRPr>
-            </a:pPr>
-            <a:r>
-              <a:t>Compares candidate's extracted skills against official corporate selection criteria.</a:t>
-            </a:r>
-          </a:p>
-          <a:p>
-            <a:pPr>
-              <a:defRPr sz="1000" b="1">
-                <a:solidFill>
-                  <a:srgbClr val="0F172A"/>
-                </a:solidFill>
-              </a:defRPr>
-            </a:pPr>
-            <a:r>
-              <a:t>Match Status Verdict:</a:t>
-            </a:r>
-          </a:p>
-          <a:p>
-            <a:pPr>
-              <a:defRPr sz="900">
-                <a:solidFill>
-                  <a:srgbClr val="64748B"/>
-                </a:solidFill>
-              </a:defRPr>
-            </a:pPr>
-            <a:r>
-              <a:t>Provides instant classification: 'Strong Match', 'Moderate Gap', or 'Action Needed'.</a:t>
-            </a:r>
-          </a:p>
-          <a:p>
-            <a:pPr>
-              <a:defRPr sz="1000" b="1">
-                <a:solidFill>
-                  <a:srgbClr val="0F172A"/>
-                </a:solidFill>
-              </a:defRPr>
-            </a:pPr>
-            <a:r>
-              <a:t>1-Click Learning Addition:</a:t>
-            </a:r>
-          </a:p>
-          <a:p>
-            <a:pPr>
-              <a:defRPr sz="900">
-                <a:solidFill>
-                  <a:srgbClr val="64748B"/>
-                </a:solidFill>
-              </a:defRPr>
-            </a:pPr>
-            <a:r>
-              <a:t>Identifies exact missing competencies and adds them directly to the student's learning roadmap.</a:t>
-            </a:r>
-          </a:p>
-        </p:txBody>
-      </p:sp>
-      <p:sp>
-        <p:nvSpPr>
-          <p:cNvPr id="7" name="Rounded Rectangle 6"/>
-          <p:cNvSpPr/>
-          <p:nvPr/>
-        </p:nvSpPr>
-        <p:spPr>
-          <a:xfrm>
-            <a:off x="8046720" y="1325880"/>
-            <a:ext cx="3401568" cy="4937760"/>
-          </a:xfrm>
-          <a:prstGeom prst="roundRect">
-            <a:avLst/>
-          </a:prstGeom>
-          <a:solidFill>
-            <a:srgbClr val="FFFFFF"/>
-          </a:solidFill>
-          <a:ln w="19050">
-            <a:solidFill>
-              <a:srgbClr val="E2E8F0"/>
-            </a:solidFill>
-          </a:ln>
-        </p:spPr>
-        <p:style>
-          <a:lnRef idx="1">
-            <a:schemeClr val="accent1"/>
-          </a:lnRef>
-          <a:fillRef idx="3">
-            <a:schemeClr val="accent1"/>
-          </a:fillRef>
-          <a:effectRef idx="2">
-            <a:schemeClr val="accent1"/>
-          </a:effectRef>
-          <a:fontRef idx="minor">
-            <a:schemeClr val="lt1"/>
-          </a:fontRef>
-        </p:style>
-        <p:txBody>
-          <a:bodyPr rtlCol="0" anchor="ctr" wrap="square"/>
-          <a:lstStyle/>
-          <a:p>
-            <a:pPr algn="ctr">
-              <a:defRPr sz="1300" b="1">
-                <a:solidFill>
-                  <a:srgbClr val="0284C7"/>
-                </a:solidFill>
-              </a:defRPr>
-            </a:pPr>
-            <a:r>
-              <a:t>Disha AI Assistant</a:t>
-            </a:r>
-          </a:p>
-          <a:p>
-            <a:pPr>
-              <a:defRPr sz="1000" b="1">
-                <a:solidFill>
-                  <a:srgbClr val="0F172A"/>
-                </a:solidFill>
-              </a:defRPr>
-            </a:pPr>
-            <a:r>
-              <a:t>24/7 Portal Guidance:</a:t>
-            </a:r>
-          </a:p>
-          <a:p>
-            <a:pPr>
-              <a:defRPr sz="900">
-                <a:solidFill>
-                  <a:srgbClr val="64748B"/>
-                </a:solidFill>
-              </a:defRPr>
-            </a:pPr>
-            <a:r>
-              <a:t>Conversational assistant grounded via Hybrid RAG to help students navigate when stuck.</a:t>
-            </a:r>
-          </a:p>
-          <a:p>
-            <a:pPr>
-              <a:defRPr sz="1000" b="1">
-                <a:solidFill>
-                  <a:srgbClr val="0F172A"/>
-                </a:solidFill>
-              </a:defRPr>
-            </a:pPr>
-            <a:r>
-              <a:t>Internship Inquiries:</a:t>
-            </a:r>
-          </a:p>
-          <a:p>
-            <a:pPr>
-              <a:defRPr sz="900">
-                <a:solidFill>
-                  <a:srgbClr val="64748B"/>
-                </a:solidFill>
-              </a:defRPr>
-            </a:pPr>
-            <a:r>
-              <a:t>Instantly queries corporate listings across 24 sectors, stipend rules (₹5k/mo + ₹6k grant), and eligibility.</a:t>
-            </a:r>
-          </a:p>
-          <a:p>
-            <a:pPr>
-              <a:defRPr sz="1000" b="1">
-                <a:solidFill>
-                  <a:srgbClr val="0F172A"/>
-                </a:solidFill>
-              </a:defRPr>
-            </a:pPr>
-            <a:r>
-              <a:t>General Career Advice:</a:t>
-            </a:r>
-          </a:p>
-          <a:p>
-            <a:pPr>
-              <a:defRPr sz="900">
-                <a:solidFill>
-                  <a:srgbClr val="64748B"/>
-                </a:solidFill>
-              </a:defRPr>
-            </a:pPr>
-            <a:r>
-              <a:t>Provides grounded answers to career questions without hallucinations.</a:t>
-            </a:r>
-          </a:p>
-        </p:txBody>
-      </p:sp>
+      </p:pic>
     </p:spTree>
   </p:cSld>
   <p:clrMapOvr>
@@ -6424,7 +6278,7 @@
             <a:avLst/>
           </a:prstGeom>
           <a:solidFill>
-            <a:srgbClr val="0F172A"/>
+            <a:srgbClr val="0B132B"/>
           </a:solidFill>
           <a:ln>
             <a:noFill/>
@@ -6454,14 +6308,68 @@
       </p:sp>
       <p:sp>
         <p:nvSpPr>
-          <p:cNvPr id="3" name="TextBox 2"/>
+          <p:cNvPr id="3" name="Rounded Rectangle 2"/>
+          <p:cNvSpPr/>
+          <p:nvPr/>
+        </p:nvSpPr>
+        <p:spPr>
+          <a:xfrm>
+            <a:off x="731520" y="347472"/>
+            <a:ext cx="3840480" cy="256032"/>
+          </a:xfrm>
+          <a:prstGeom prst="roundRect">
+            <a:avLst/>
+          </a:prstGeom>
+          <a:solidFill>
+            <a:srgbClr val="1C2541"/>
+          </a:solidFill>
+          <a:ln w="12700">
+            <a:solidFill>
+              <a:srgbClr val="F97316"/>
+            </a:solidFill>
+          </a:ln>
+        </p:spPr>
+        <p:style>
+          <a:lnRef idx="1">
+            <a:schemeClr val="accent1"/>
+          </a:lnRef>
+          <a:fillRef idx="3">
+            <a:schemeClr val="accent1"/>
+          </a:fillRef>
+          <a:effectRef idx="2">
+            <a:schemeClr val="accent1"/>
+          </a:effectRef>
+          <a:fontRef idx="minor">
+            <a:schemeClr val="lt1"/>
+          </a:fontRef>
+        </p:style>
+        <p:txBody>
+          <a:bodyPr rtlCol="0" anchor="ctr" wrap="none"/>
+          <a:lstStyle/>
+          <a:p>
+            <a:pPr algn="ctr">
+              <a:defRPr sz="850" b="1">
+                <a:solidFill>
+                  <a:srgbClr val="F97316"/>
+                </a:solidFill>
+              </a:defRPr>
+            </a:pPr>
+            <a:r>
+              <a:t>PRODUCTION-GRADE 4-TIER AI ARCHITECTURE</a:t>
+            </a:r>
+          </a:p>
+        </p:txBody>
+      </p:sp>
+      <p:sp>
+        <p:nvSpPr>
+          <p:cNvPr id="4" name="TextBox 3"/>
           <p:cNvSpPr txBox="1"/>
           <p:nvPr/>
         </p:nvSpPr>
         <p:spPr>
           <a:xfrm>
-            <a:off x="731520" y="365760"/>
-            <a:ext cx="10515600" cy="320040"/>
+            <a:off x="731520" y="640080"/>
+            <a:ext cx="10698480" cy="594360"/>
           </a:xfrm>
           <a:prstGeom prst="rect">
             <a:avLst/>
@@ -6475,44 +6383,9 @@
           <a:lstStyle/>
           <a:p>
             <a:pPr>
-              <a:defRPr sz="1000" b="1">
-                <a:solidFill>
-                  <a:srgbClr val="EA580C"/>
-                </a:solidFill>
-              </a:defRPr>
-            </a:pPr>
-            <a:r>
-              <a:t>MODULAR 4-TIER AI ARCHITECTURE</a:t>
-            </a:r>
-          </a:p>
-        </p:txBody>
-      </p:sp>
-      <p:sp>
-        <p:nvSpPr>
-          <p:cNvPr id="4" name="TextBox 3"/>
-          <p:cNvSpPr txBox="1"/>
-          <p:nvPr/>
-        </p:nvSpPr>
-        <p:spPr>
-          <a:xfrm>
-            <a:off x="731520" y="658368"/>
-            <a:ext cx="10515600" cy="548640"/>
-          </a:xfrm>
-          <a:prstGeom prst="rect">
-            <a:avLst/>
-          </a:prstGeom>
-          <a:noFill/>
-        </p:spPr>
-        <p:txBody>
-          <a:bodyPr wrap="square">
-            <a:spAutoFit/>
-          </a:bodyPr>
-          <a:lstStyle/>
-          <a:p>
-            <a:pPr>
-              <a:defRPr sz="2200" b="1">
-                <a:solidFill>
-                  <a:srgbClr val="F1F5F9"/>
+              <a:defRPr sz="2100" b="1">
+                <a:solidFill>
+                  <a:srgbClr val="F8FAFC"/>
                 </a:solidFill>
               </a:defRPr>
             </a:pPr>
@@ -6524,7 +6397,7 @@
       </p:sp>
       <p:pic>
         <p:nvPicPr>
-          <p:cNvPr id="5" name="Picture 4" descr="architecture_diagram.png"/>
+          <p:cNvPr id="5" name="Picture 4" descr="tech_architecture_pro.png"/>
           <p:cNvPicPr>
             <a:picLocks noChangeAspect="1"/>
           </p:cNvPicPr>
@@ -6538,8 +6411,8 @@
         </p:blipFill>
         <p:spPr>
           <a:xfrm>
-            <a:off x="731520" y="1371600"/>
-            <a:ext cx="5669280" cy="2346358"/>
+            <a:off x="731520" y="1325880"/>
+            <a:ext cx="6035040" cy="2495257"/>
           </a:xfrm>
           <a:prstGeom prst="rect">
             <a:avLst/>
@@ -6554,16 +6427,16 @@
         </p:nvSpPr>
         <p:spPr>
           <a:xfrm>
-            <a:off x="6675120" y="1371600"/>
-            <a:ext cx="4754880" cy="4892040"/>
+            <a:off x="6949440" y="1325880"/>
+            <a:ext cx="4480560" cy="4983480"/>
           </a:xfrm>
           <a:prstGeom prst="roundRect">
             <a:avLst/>
           </a:prstGeom>
           <a:solidFill>
-            <a:srgbClr val="1E293B"/>
+            <a:srgbClr val="1C2541"/>
           </a:solidFill>
-          <a:ln w="12700">
+          <a:ln w="15240">
             <a:solidFill>
               <a:srgbClr val="334155"/>
             </a:solidFill>
@@ -6588,21 +6461,21 @@
           <a:lstStyle/>
           <a:p>
             <a:pPr algn="ctr">
-              <a:defRPr sz="1300" b="1">
+              <a:defRPr sz="1250" b="1">
                 <a:solidFill>
                   <a:srgbClr val="10B981"/>
                 </a:solidFill>
               </a:defRPr>
             </a:pPr>
             <a:r>
-              <a:t>Technical Specifications &amp; AI Pipeline</a:t>
-            </a:r>
-          </a:p>
-          <a:p>
-            <a:pPr>
-              <a:defRPr sz="1000" b="1">
-                <a:solidFill>
-                  <a:srgbClr val="F1F5F9"/>
+              <a:t>Technical Architecture &amp; AI Pipeline</a:t>
+            </a:r>
+          </a:p>
+          <a:p>
+            <a:pPr>
+              <a:defRPr sz="950" b="1">
+                <a:solidFill>
+                  <a:srgbClr val="F8FAFC"/>
                 </a:solidFill>
               </a:defRPr>
             </a:pPr>
@@ -6612,21 +6485,21 @@
           </a:p>
           <a:p>
             <a:pPr>
-              <a:defRPr sz="880">
+              <a:defRPr sz="840">
                 <a:solidFill>
                   <a:srgbClr val="94A3B8"/>
                 </a:solidFill>
               </a:defRPr>
             </a:pPr>
             <a:r>
-              <a:t>React 19, Tailwind CSS, TanStack Router with client-side state caching, high-contrast accessible typography, and dark/light system adaptation.</a:t>
-            </a:r>
-          </a:p>
-          <a:p>
-            <a:pPr>
-              <a:defRPr sz="1000" b="1">
-                <a:solidFill>
-                  <a:srgbClr val="F1F5F9"/>
+              <a:t>Built with React 19, Vite 8, and Tailwind CSS. Client-side state caching, high-contrast accessible typography, and automatic dark/light theme switching.</a:t>
+            </a:r>
+          </a:p>
+          <a:p>
+            <a:pPr>
+              <a:defRPr sz="950" b="1">
+                <a:solidFill>
+                  <a:srgbClr val="F8FAFC"/>
                 </a:solidFill>
               </a:defRPr>
             </a:pPr>
@@ -6636,21 +6509,21 @@
           </a:p>
           <a:p>
             <a:pPr>
-              <a:defRPr sz="880">
+              <a:defRPr sz="840">
                 <a:solidFill>
                   <a:srgbClr val="94A3B8"/>
                 </a:solidFill>
               </a:defRPr>
             </a:pPr>
             <a:r>
-              <a:t>FastAPI microservices delivering &lt;15ms response times, JWT session security, multipart PDF/DOCX resume text extraction, and Cloudinary storage.</a:t>
-            </a:r>
-          </a:p>
-          <a:p>
-            <a:pPr>
-              <a:defRPr sz="1000" b="1">
-                <a:solidFill>
-                  <a:srgbClr val="F1F5F9"/>
+              <a:t>FastAPI microservices delivering &lt;15ms response latency, JWT session authentication, multipart PDF/DOCX extractors, and secure Cloudinary storage.</a:t>
+            </a:r>
+          </a:p>
+          <a:p>
+            <a:pPr>
+              <a:defRPr sz="950" b="1">
+                <a:solidFill>
+                  <a:srgbClr val="F8FAFC"/>
                 </a:solidFill>
               </a:defRPr>
             </a:pPr>
@@ -6660,21 +6533,21 @@
           </a:p>
           <a:p>
             <a:pPr>
-              <a:defRPr sz="880">
+              <a:defRPr sz="840">
                 <a:solidFill>
                   <a:srgbClr val="94A3B8"/>
                 </a:solidFill>
               </a:defRPr>
             </a:pPr>
             <a:r>
-              <a:t>Combines Qdrant dense vector search (1024-dim semantic embeddings) with Rank-BM25 lexical search using Reciprocal Rank Fusion (RRF).</a:t>
-            </a:r>
-          </a:p>
-          <a:p>
-            <a:pPr>
-              <a:defRPr sz="1000" b="1">
-                <a:solidFill>
-                  <a:srgbClr val="F1F5F9"/>
+              <a:t>Combines Qdrant dense vector search (1024-dim semantic embeddings) with Rank-BM25 lexical ranking via Reciprocal Rank Fusion (RRF) for 100% precision.</a:t>
+            </a:r>
+          </a:p>
+          <a:p>
+            <a:pPr>
+              <a:defRPr sz="950" b="1">
+                <a:solidFill>
+                  <a:srgbClr val="F8FAFC"/>
                 </a:solidFill>
               </a:defRPr>
             </a:pPr>
@@ -6684,7 +6557,7 @@
           </a:p>
           <a:p>
             <a:pPr>
-              <a:defRPr sz="880">
+              <a:defRPr sz="840">
                 <a:solidFill>
                   <a:srgbClr val="94A3B8"/>
                 </a:solidFill>
@@ -6696,9 +6569,9 @@
           </a:p>
           <a:p>
             <a:pPr>
-              <a:defRPr sz="1000" b="1">
-                <a:solidFill>
-                  <a:srgbClr val="F1F5F9"/>
+              <a:defRPr sz="950" b="1">
+                <a:solidFill>
+                  <a:srgbClr val="F8FAFC"/>
                 </a:solidFill>
               </a:defRPr>
             </a:pPr>
@@ -6708,7 +6581,7 @@
           </a:p>
           <a:p>
             <a:pPr>
-              <a:defRPr sz="880">
+              <a:defRPr sz="840">
                 <a:solidFill>
                   <a:srgbClr val="94A3B8"/>
                 </a:solidFill>
@@ -6783,14 +6656,68 @@
       </p:sp>
       <p:sp>
         <p:nvSpPr>
-          <p:cNvPr id="3" name="TextBox 2"/>
+          <p:cNvPr id="3" name="Rounded Rectangle 2"/>
+          <p:cNvSpPr/>
+          <p:nvPr/>
+        </p:nvSpPr>
+        <p:spPr>
+          <a:xfrm>
+            <a:off x="731520" y="347472"/>
+            <a:ext cx="3840480" cy="256032"/>
+          </a:xfrm>
+          <a:prstGeom prst="roundRect">
+            <a:avLst/>
+          </a:prstGeom>
+          <a:solidFill>
+            <a:srgbClr val="FFF7ED"/>
+          </a:solidFill>
+          <a:ln w="12700">
+            <a:solidFill>
+              <a:srgbClr val="F97316"/>
+            </a:solidFill>
+          </a:ln>
+        </p:spPr>
+        <p:style>
+          <a:lnRef idx="1">
+            <a:schemeClr val="accent1"/>
+          </a:lnRef>
+          <a:fillRef idx="3">
+            <a:schemeClr val="accent1"/>
+          </a:fillRef>
+          <a:effectRef idx="2">
+            <a:schemeClr val="accent1"/>
+          </a:effectRef>
+          <a:fontRef idx="minor">
+            <a:schemeClr val="lt1"/>
+          </a:fontRef>
+        </p:style>
+        <p:txBody>
+          <a:bodyPr rtlCol="0" anchor="ctr" wrap="none"/>
+          <a:lstStyle/>
+          <a:p>
+            <a:pPr algn="ctr">
+              <a:defRPr sz="850" b="1">
+                <a:solidFill>
+                  <a:srgbClr val="F97316"/>
+                </a:solidFill>
+              </a:defRPr>
+            </a:pPr>
+            <a:r>
+              <a:t>PRODUCTION IMPACT &amp; STRATEGIC ROADMAP</a:t>
+            </a:r>
+          </a:p>
+        </p:txBody>
+      </p:sp>
+      <p:sp>
+        <p:nvSpPr>
+          <p:cNvPr id="4" name="TextBox 3"/>
           <p:cNvSpPr txBox="1"/>
           <p:nvPr/>
         </p:nvSpPr>
         <p:spPr>
           <a:xfrm>
-            <a:off x="731520" y="365760"/>
-            <a:ext cx="10515600" cy="320040"/>
+            <a:off x="731520" y="640080"/>
+            <a:ext cx="10698480" cy="594360"/>
           </a:xfrm>
           <a:prstGeom prst="rect">
             <a:avLst/>
@@ -6804,42 +6731,7 @@
           <a:lstStyle/>
           <a:p>
             <a:pPr>
-              <a:defRPr sz="1000" b="1">
-                <a:solidFill>
-                  <a:srgbClr val="EA580C"/>
-                </a:solidFill>
-              </a:defRPr>
-            </a:pPr>
-            <a:r>
-              <a:t>PRODUCTION IMPACT &amp; STRATEGIC ROADMAP</a:t>
-            </a:r>
-          </a:p>
-        </p:txBody>
-      </p:sp>
-      <p:sp>
-        <p:nvSpPr>
-          <p:cNvPr id="4" name="TextBox 3"/>
-          <p:cNvSpPr txBox="1"/>
-          <p:nvPr/>
-        </p:nvSpPr>
-        <p:spPr>
-          <a:xfrm>
-            <a:off x="731520" y="658368"/>
-            <a:ext cx="10515600" cy="548640"/>
-          </a:xfrm>
-          <a:prstGeom prst="rect">
-            <a:avLst/>
-          </a:prstGeom>
-          <a:noFill/>
-        </p:spPr>
-        <p:txBody>
-          <a:bodyPr wrap="square">
-            <a:spAutoFit/>
-          </a:bodyPr>
-          <a:lstStyle/>
-          <a:p>
-            <a:pPr>
-              <a:defRPr sz="2200" b="1">
+              <a:defRPr sz="2100" b="1">
                 <a:solidFill>
                   <a:srgbClr val="0F172A"/>
                 </a:solidFill>
@@ -6895,7 +6787,7 @@
             <a:pPr algn="ctr">
               <a:defRPr sz="1200" b="1">
                 <a:solidFill>
-                  <a:srgbClr val="0284C7"/>
+                  <a:srgbClr val="0EA5E9"/>
                 </a:solidFill>
               </a:defRPr>
             </a:pPr>
@@ -7075,7 +6967,7 @@
             <a:pPr algn="ctr">
               <a:defRPr sz="1200" b="1">
                 <a:solidFill>
-                  <a:srgbClr val="EA580C"/>
+                  <a:srgbClr val="F97316"/>
                 </a:solidFill>
               </a:defRPr>
             </a:pPr>
@@ -7165,7 +7057,7 @@
             <a:pPr algn="ctr">
               <a:defRPr sz="1200" b="1">
                 <a:solidFill>
-                  <a:srgbClr val="4F46E5"/>
+                  <a:srgbClr val="6366F1"/>
                 </a:solidFill>
               </a:defRPr>
             </a:pPr>

</xml_diff>